<commit_message>
ep.02-hide all revit links complted
check the items and download it
</commit_message>
<xml_diff>
--- a/Master Presentation/BIM && YOU - Master Presentation.pptx
+++ b/Master Presentation/BIM && YOU - Master Presentation.pptx
@@ -14,28 +14,36 @@
     <p:sldId id="259" r:id="rId9"/>
     <p:sldId id="260" r:id="rId10"/>
     <p:sldId id="261" r:id="rId11"/>
+    <p:sldId id="262" r:id="rId12"/>
+    <p:sldId id="263" r:id="rId13"/>
+    <p:sldId id="264" r:id="rId14"/>
+    <p:sldId id="265" r:id="rId15"/>
+    <p:sldId id="266" r:id="rId16"/>
+    <p:sldId id="267" r:id="rId17"/>
+    <p:sldId id="268" r:id="rId18"/>
+    <p:sldId id="269" r:id="rId19"/>
   </p:sldIdLst>
   <p:sldSz cy="6858000" cx="12192000"/>
   <p:notesSz cx="6858000" cy="9144000"/>
   <p:embeddedFontLst>
     <p:embeddedFont>
       <p:font typeface="Inter SemiBold"/>
-      <p:regular r:id="rId12"/>
-      <p:bold r:id="rId13"/>
-      <p:italic r:id="rId14"/>
-      <p:boldItalic r:id="rId15"/>
+      <p:regular r:id="rId20"/>
+      <p:bold r:id="rId21"/>
+      <p:italic r:id="rId22"/>
+      <p:boldItalic r:id="rId23"/>
     </p:embeddedFont>
     <p:embeddedFont>
       <p:font typeface="Inter"/>
-      <p:regular r:id="rId16"/>
-      <p:bold r:id="rId17"/>
-      <p:italic r:id="rId18"/>
-      <p:boldItalic r:id="rId19"/>
+      <p:regular r:id="rId24"/>
+      <p:bold r:id="rId25"/>
+      <p:italic r:id="rId26"/>
+      <p:boldItalic r:id="rId27"/>
     </p:embeddedFont>
     <p:embeddedFont>
       <p:font typeface="Inter ExtraBold"/>
-      <p:bold r:id="rId20"/>
-      <p:boldItalic r:id="rId21"/>
+      <p:bold r:id="rId28"/>
+      <p:boldItalic r:id="rId29"/>
     </p:embeddedFont>
   </p:embeddedFontLst>
   <p:defaultTextStyle>
@@ -811,6 +819,501 @@
 </p:notes>
 </file>
 
+<file path=ppt/notesSlides/notesSlide10.xml><?xml version="1.0" encoding="utf-8"?>
+<p:notes xmlns:a="http://schemas.openxmlformats.org/drawingml/2006/main" xmlns:r="http://schemas.openxmlformats.org/officeDocument/2006/relationships" xmlns:mc="http://schemas.openxmlformats.org/markup-compatibility/2006" xmlns:mv="urn:schemas-microsoft-com:mac:vml" xmlns:p="http://schemas.openxmlformats.org/presentationml/2006/main" xmlns:c="http://schemas.openxmlformats.org/drawingml/2006/chart" xmlns:dgm="http://schemas.openxmlformats.org/drawingml/2006/diagram" xmlns:o="urn:schemas-microsoft-com:office:office" xmlns:v="urn:schemas-microsoft-com:vml" xmlns:pvml="urn:schemas-microsoft-com:office:powerpoint" xmlns:com="http://schemas.openxmlformats.org/drawingml/2006/compatibility" xmlns:p14="http://schemas.microsoft.com/office/powerpoint/2010/main" xmlns:p15="http://schemas.microsoft.com/office/powerpoint/2012/main" xmlns:ahyp="http://schemas.microsoft.com/office/drawing/2018/hyperlinkcolor" showMasterPhAnim="0" showMasterSp="0">
+  <p:cSld>
+    <p:spTree>
+      <p:nvGrpSpPr>
+        <p:cNvPr id="185" name="Shape 185"/>
+        <p:cNvGrpSpPr/>
+        <p:nvPr/>
+      </p:nvGrpSpPr>
+      <p:grpSpPr>
+        <a:xfrm>
+          <a:off x="0" y="0"/>
+          <a:ext cx="0" cy="0"/>
+          <a:chOff x="0" y="0"/>
+          <a:chExt cx="0" cy="0"/>
+        </a:xfrm>
+      </p:grpSpPr>
+      <p:sp>
+        <p:nvSpPr>
+          <p:cNvPr id="186" name="Google Shape;186;g3fb6c4c2bd7_0_35:notes"/>
+          <p:cNvSpPr txBox="1"/>
+          <p:nvPr>
+            <p:ph idx="1" type="body"/>
+          </p:nvPr>
+        </p:nvSpPr>
+        <p:spPr>
+          <a:xfrm>
+            <a:off x="685800" y="4343400"/>
+            <a:ext cx="5486400" cy="4114800"/>
+          </a:xfrm>
+          <a:prstGeom prst="rect">
+            <a:avLst/>
+          </a:prstGeom>
+        </p:spPr>
+        <p:txBody>
+          <a:bodyPr anchorCtr="0" anchor="t" bIns="91425" lIns="91425" spcFirstLastPara="1" rIns="91425" wrap="square" tIns="91425">
+            <a:noAutofit/>
+          </a:bodyPr>
+          <a:lstStyle/>
+          <a:p>
+            <a:pPr indent="0" lvl="0" marL="0" rtl="0" algn="l">
+              <a:spcBef>
+                <a:spcPts val="0"/>
+              </a:spcBef>
+              <a:spcAft>
+                <a:spcPts val="0"/>
+              </a:spcAft>
+              <a:buNone/>
+            </a:pPr>
+            <a:r>
+              <a:t/>
+            </a:r>
+            <a:endParaRPr/>
+          </a:p>
+        </p:txBody>
+      </p:sp>
+      <p:sp>
+        <p:nvSpPr>
+          <p:cNvPr id="187" name="Google Shape;187;g3fb6c4c2bd7_0_35:notes"/>
+          <p:cNvSpPr/>
+          <p:nvPr>
+            <p:ph idx="2" type="sldImg"/>
+          </p:nvPr>
+        </p:nvSpPr>
+        <p:spPr>
+          <a:xfrm>
+            <a:off x="1143225" y="685800"/>
+            <a:ext cx="4572300" cy="3429000"/>
+          </a:xfrm>
+          <a:custGeom>
+            <a:rect b="b" l="l" r="r" t="t"/>
+            <a:pathLst>
+              <a:path extrusionOk="0" h="120000" w="120000">
+                <a:moveTo>
+                  <a:pt x="0" y="0"/>
+                </a:moveTo>
+                <a:lnTo>
+                  <a:pt x="120000" y="0"/>
+                </a:lnTo>
+                <a:lnTo>
+                  <a:pt x="120000" y="120000"/>
+                </a:lnTo>
+                <a:lnTo>
+                  <a:pt x="0" y="120000"/>
+                </a:lnTo>
+                <a:close/>
+              </a:path>
+            </a:pathLst>
+          </a:custGeom>
+        </p:spPr>
+      </p:sp>
+    </p:spTree>
+  </p:cSld>
+  <p:clrMapOvr>
+    <a:masterClrMapping/>
+  </p:clrMapOvr>
+</p:notes>
+</file>
+
+<file path=ppt/notesSlides/notesSlide11.xml><?xml version="1.0" encoding="utf-8"?>
+<p:notes xmlns:a="http://schemas.openxmlformats.org/drawingml/2006/main" xmlns:r="http://schemas.openxmlformats.org/officeDocument/2006/relationships" xmlns:mc="http://schemas.openxmlformats.org/markup-compatibility/2006" xmlns:mv="urn:schemas-microsoft-com:mac:vml" xmlns:p="http://schemas.openxmlformats.org/presentationml/2006/main" xmlns:c="http://schemas.openxmlformats.org/drawingml/2006/chart" xmlns:dgm="http://schemas.openxmlformats.org/drawingml/2006/diagram" xmlns:o="urn:schemas-microsoft-com:office:office" xmlns:v="urn:schemas-microsoft-com:vml" xmlns:pvml="urn:schemas-microsoft-com:office:powerpoint" xmlns:com="http://schemas.openxmlformats.org/drawingml/2006/compatibility" xmlns:p14="http://schemas.microsoft.com/office/powerpoint/2010/main" xmlns:p15="http://schemas.microsoft.com/office/powerpoint/2012/main" xmlns:ahyp="http://schemas.microsoft.com/office/drawing/2018/hyperlinkcolor" showMasterPhAnim="0" showMasterSp="0">
+  <p:cSld>
+    <p:spTree>
+      <p:nvGrpSpPr>
+        <p:cNvPr id="195" name="Shape 195"/>
+        <p:cNvGrpSpPr/>
+        <p:nvPr/>
+      </p:nvGrpSpPr>
+      <p:grpSpPr>
+        <a:xfrm>
+          <a:off x="0" y="0"/>
+          <a:ext cx="0" cy="0"/>
+          <a:chOff x="0" y="0"/>
+          <a:chExt cx="0" cy="0"/>
+        </a:xfrm>
+      </p:grpSpPr>
+      <p:sp>
+        <p:nvSpPr>
+          <p:cNvPr id="196" name="Google Shape;196;g3fb6c4c2bd7_0_44:notes"/>
+          <p:cNvSpPr txBox="1"/>
+          <p:nvPr>
+            <p:ph idx="1" type="body"/>
+          </p:nvPr>
+        </p:nvSpPr>
+        <p:spPr>
+          <a:xfrm>
+            <a:off x="685800" y="4343400"/>
+            <a:ext cx="5486400" cy="4114800"/>
+          </a:xfrm>
+          <a:prstGeom prst="rect">
+            <a:avLst/>
+          </a:prstGeom>
+        </p:spPr>
+        <p:txBody>
+          <a:bodyPr anchorCtr="0" anchor="t" bIns="91425" lIns="91425" spcFirstLastPara="1" rIns="91425" wrap="square" tIns="91425">
+            <a:noAutofit/>
+          </a:bodyPr>
+          <a:lstStyle/>
+          <a:p>
+            <a:pPr indent="0" lvl="0" marL="0" rtl="0" algn="l">
+              <a:spcBef>
+                <a:spcPts val="0"/>
+              </a:spcBef>
+              <a:spcAft>
+                <a:spcPts val="0"/>
+              </a:spcAft>
+              <a:buNone/>
+            </a:pPr>
+            <a:r>
+              <a:t/>
+            </a:r>
+            <a:endParaRPr/>
+          </a:p>
+        </p:txBody>
+      </p:sp>
+      <p:sp>
+        <p:nvSpPr>
+          <p:cNvPr id="197" name="Google Shape;197;g3fb6c4c2bd7_0_44:notes"/>
+          <p:cNvSpPr/>
+          <p:nvPr>
+            <p:ph idx="2" type="sldImg"/>
+          </p:nvPr>
+        </p:nvSpPr>
+        <p:spPr>
+          <a:xfrm>
+            <a:off x="1143225" y="685800"/>
+            <a:ext cx="4572300" cy="3429000"/>
+          </a:xfrm>
+          <a:custGeom>
+            <a:rect b="b" l="l" r="r" t="t"/>
+            <a:pathLst>
+              <a:path extrusionOk="0" h="120000" w="120000">
+                <a:moveTo>
+                  <a:pt x="0" y="0"/>
+                </a:moveTo>
+                <a:lnTo>
+                  <a:pt x="120000" y="0"/>
+                </a:lnTo>
+                <a:lnTo>
+                  <a:pt x="120000" y="120000"/>
+                </a:lnTo>
+                <a:lnTo>
+                  <a:pt x="0" y="120000"/>
+                </a:lnTo>
+                <a:close/>
+              </a:path>
+            </a:pathLst>
+          </a:custGeom>
+        </p:spPr>
+      </p:sp>
+    </p:spTree>
+  </p:cSld>
+  <p:clrMapOvr>
+    <a:masterClrMapping/>
+  </p:clrMapOvr>
+</p:notes>
+</file>
+
+<file path=ppt/notesSlides/notesSlide12.xml><?xml version="1.0" encoding="utf-8"?>
+<p:notes xmlns:a="http://schemas.openxmlformats.org/drawingml/2006/main" xmlns:r="http://schemas.openxmlformats.org/officeDocument/2006/relationships" xmlns:mc="http://schemas.openxmlformats.org/markup-compatibility/2006" xmlns:mv="urn:schemas-microsoft-com:mac:vml" xmlns:p="http://schemas.openxmlformats.org/presentationml/2006/main" xmlns:c="http://schemas.openxmlformats.org/drawingml/2006/chart" xmlns:dgm="http://schemas.openxmlformats.org/drawingml/2006/diagram" xmlns:o="urn:schemas-microsoft-com:office:office" xmlns:v="urn:schemas-microsoft-com:vml" xmlns:pvml="urn:schemas-microsoft-com:office:powerpoint" xmlns:com="http://schemas.openxmlformats.org/drawingml/2006/compatibility" xmlns:p14="http://schemas.microsoft.com/office/powerpoint/2010/main" xmlns:p15="http://schemas.microsoft.com/office/powerpoint/2012/main" xmlns:ahyp="http://schemas.microsoft.com/office/drawing/2018/hyperlinkcolor" showMasterPhAnim="0" showMasterSp="0">
+  <p:cSld>
+    <p:spTree>
+      <p:nvGrpSpPr>
+        <p:cNvPr id="206" name="Shape 206"/>
+        <p:cNvGrpSpPr/>
+        <p:nvPr/>
+      </p:nvGrpSpPr>
+      <p:grpSpPr>
+        <a:xfrm>
+          <a:off x="0" y="0"/>
+          <a:ext cx="0" cy="0"/>
+          <a:chOff x="0" y="0"/>
+          <a:chExt cx="0" cy="0"/>
+        </a:xfrm>
+      </p:grpSpPr>
+      <p:sp>
+        <p:nvSpPr>
+          <p:cNvPr id="207" name="Google Shape;207;g3fb6c4c2bd7_0_54:notes"/>
+          <p:cNvSpPr txBox="1"/>
+          <p:nvPr>
+            <p:ph idx="1" type="body"/>
+          </p:nvPr>
+        </p:nvSpPr>
+        <p:spPr>
+          <a:xfrm>
+            <a:off x="685800" y="4343400"/>
+            <a:ext cx="5486400" cy="4114800"/>
+          </a:xfrm>
+          <a:prstGeom prst="rect">
+            <a:avLst/>
+          </a:prstGeom>
+        </p:spPr>
+        <p:txBody>
+          <a:bodyPr anchorCtr="0" anchor="t" bIns="91425" lIns="91425" spcFirstLastPara="1" rIns="91425" wrap="square" tIns="91425">
+            <a:noAutofit/>
+          </a:bodyPr>
+          <a:lstStyle/>
+          <a:p>
+            <a:pPr indent="0" lvl="0" marL="0" rtl="0" algn="l">
+              <a:spcBef>
+                <a:spcPts val="0"/>
+              </a:spcBef>
+              <a:spcAft>
+                <a:spcPts val="0"/>
+              </a:spcAft>
+              <a:buNone/>
+            </a:pPr>
+            <a:r>
+              <a:t/>
+            </a:r>
+            <a:endParaRPr/>
+          </a:p>
+        </p:txBody>
+      </p:sp>
+      <p:sp>
+        <p:nvSpPr>
+          <p:cNvPr id="208" name="Google Shape;208;g3fb6c4c2bd7_0_54:notes"/>
+          <p:cNvSpPr/>
+          <p:nvPr>
+            <p:ph idx="2" type="sldImg"/>
+          </p:nvPr>
+        </p:nvSpPr>
+        <p:spPr>
+          <a:xfrm>
+            <a:off x="1143225" y="685800"/>
+            <a:ext cx="4572300" cy="3429000"/>
+          </a:xfrm>
+          <a:custGeom>
+            <a:rect b="b" l="l" r="r" t="t"/>
+            <a:pathLst>
+              <a:path extrusionOk="0" h="120000" w="120000">
+                <a:moveTo>
+                  <a:pt x="0" y="0"/>
+                </a:moveTo>
+                <a:lnTo>
+                  <a:pt x="120000" y="0"/>
+                </a:lnTo>
+                <a:lnTo>
+                  <a:pt x="120000" y="120000"/>
+                </a:lnTo>
+                <a:lnTo>
+                  <a:pt x="0" y="120000"/>
+                </a:lnTo>
+                <a:close/>
+              </a:path>
+            </a:pathLst>
+          </a:custGeom>
+        </p:spPr>
+      </p:sp>
+    </p:spTree>
+  </p:cSld>
+  <p:clrMapOvr>
+    <a:masterClrMapping/>
+  </p:clrMapOvr>
+</p:notes>
+</file>
+
+<file path=ppt/notesSlides/notesSlide13.xml><?xml version="1.0" encoding="utf-8"?>
+<p:notes xmlns:a="http://schemas.openxmlformats.org/drawingml/2006/main" xmlns:r="http://schemas.openxmlformats.org/officeDocument/2006/relationships" xmlns:mc="http://schemas.openxmlformats.org/markup-compatibility/2006" xmlns:mv="urn:schemas-microsoft-com:mac:vml" xmlns:p="http://schemas.openxmlformats.org/presentationml/2006/main" xmlns:c="http://schemas.openxmlformats.org/drawingml/2006/chart" xmlns:dgm="http://schemas.openxmlformats.org/drawingml/2006/diagram" xmlns:o="urn:schemas-microsoft-com:office:office" xmlns:v="urn:schemas-microsoft-com:vml" xmlns:pvml="urn:schemas-microsoft-com:office:powerpoint" xmlns:com="http://schemas.openxmlformats.org/drawingml/2006/compatibility" xmlns:p14="http://schemas.microsoft.com/office/powerpoint/2010/main" xmlns:p15="http://schemas.microsoft.com/office/powerpoint/2012/main" xmlns:ahyp="http://schemas.microsoft.com/office/drawing/2018/hyperlinkcolor" showMasterPhAnim="0" showMasterSp="0">
+  <p:cSld>
+    <p:spTree>
+      <p:nvGrpSpPr>
+        <p:cNvPr id="215" name="Shape 215"/>
+        <p:cNvGrpSpPr/>
+        <p:nvPr/>
+      </p:nvGrpSpPr>
+      <p:grpSpPr>
+        <a:xfrm>
+          <a:off x="0" y="0"/>
+          <a:ext cx="0" cy="0"/>
+          <a:chOff x="0" y="0"/>
+          <a:chExt cx="0" cy="0"/>
+        </a:xfrm>
+      </p:grpSpPr>
+      <p:sp>
+        <p:nvSpPr>
+          <p:cNvPr id="216" name="Google Shape;216;g3fb6c4c2bd7_0_66:notes"/>
+          <p:cNvSpPr txBox="1"/>
+          <p:nvPr>
+            <p:ph idx="1" type="body"/>
+          </p:nvPr>
+        </p:nvSpPr>
+        <p:spPr>
+          <a:xfrm>
+            <a:off x="685800" y="4343400"/>
+            <a:ext cx="5486400" cy="4114800"/>
+          </a:xfrm>
+          <a:prstGeom prst="rect">
+            <a:avLst/>
+          </a:prstGeom>
+        </p:spPr>
+        <p:txBody>
+          <a:bodyPr anchorCtr="0" anchor="t" bIns="91425" lIns="91425" spcFirstLastPara="1" rIns="91425" wrap="square" tIns="91425">
+            <a:noAutofit/>
+          </a:bodyPr>
+          <a:lstStyle/>
+          <a:p>
+            <a:pPr indent="0" lvl="0" marL="0" rtl="0" algn="l">
+              <a:spcBef>
+                <a:spcPts val="0"/>
+              </a:spcBef>
+              <a:spcAft>
+                <a:spcPts val="0"/>
+              </a:spcAft>
+              <a:buNone/>
+            </a:pPr>
+            <a:r>
+              <a:t/>
+            </a:r>
+            <a:endParaRPr/>
+          </a:p>
+        </p:txBody>
+      </p:sp>
+      <p:sp>
+        <p:nvSpPr>
+          <p:cNvPr id="217" name="Google Shape;217;g3fb6c4c2bd7_0_66:notes"/>
+          <p:cNvSpPr/>
+          <p:nvPr>
+            <p:ph idx="2" type="sldImg"/>
+          </p:nvPr>
+        </p:nvSpPr>
+        <p:spPr>
+          <a:xfrm>
+            <a:off x="1143225" y="685800"/>
+            <a:ext cx="4572300" cy="3429000"/>
+          </a:xfrm>
+          <a:custGeom>
+            <a:rect b="b" l="l" r="r" t="t"/>
+            <a:pathLst>
+              <a:path extrusionOk="0" h="120000" w="120000">
+                <a:moveTo>
+                  <a:pt x="0" y="0"/>
+                </a:moveTo>
+                <a:lnTo>
+                  <a:pt x="120000" y="0"/>
+                </a:lnTo>
+                <a:lnTo>
+                  <a:pt x="120000" y="120000"/>
+                </a:lnTo>
+                <a:lnTo>
+                  <a:pt x="0" y="120000"/>
+                </a:lnTo>
+                <a:close/>
+              </a:path>
+            </a:pathLst>
+          </a:custGeom>
+        </p:spPr>
+      </p:sp>
+    </p:spTree>
+  </p:cSld>
+  <p:clrMapOvr>
+    <a:masterClrMapping/>
+  </p:clrMapOvr>
+</p:notes>
+</file>
+
+<file path=ppt/notesSlides/notesSlide14.xml><?xml version="1.0" encoding="utf-8"?>
+<p:notes xmlns:a="http://schemas.openxmlformats.org/drawingml/2006/main" xmlns:r="http://schemas.openxmlformats.org/officeDocument/2006/relationships" xmlns:mc="http://schemas.openxmlformats.org/markup-compatibility/2006" xmlns:mv="urn:schemas-microsoft-com:mac:vml" xmlns:p="http://schemas.openxmlformats.org/presentationml/2006/main" xmlns:c="http://schemas.openxmlformats.org/drawingml/2006/chart" xmlns:dgm="http://schemas.openxmlformats.org/drawingml/2006/diagram" xmlns:o="urn:schemas-microsoft-com:office:office" xmlns:v="urn:schemas-microsoft-com:vml" xmlns:pvml="urn:schemas-microsoft-com:office:powerpoint" xmlns:com="http://schemas.openxmlformats.org/drawingml/2006/compatibility" xmlns:p14="http://schemas.microsoft.com/office/powerpoint/2010/main" xmlns:p15="http://schemas.microsoft.com/office/powerpoint/2012/main" xmlns:ahyp="http://schemas.microsoft.com/office/drawing/2018/hyperlinkcolor" showMasterPhAnim="0" showMasterSp="0">
+  <p:cSld>
+    <p:spTree>
+      <p:nvGrpSpPr>
+        <p:cNvPr id="222" name="Shape 222"/>
+        <p:cNvGrpSpPr/>
+        <p:nvPr/>
+      </p:nvGrpSpPr>
+      <p:grpSpPr>
+        <a:xfrm>
+          <a:off x="0" y="0"/>
+          <a:ext cx="0" cy="0"/>
+          <a:chOff x="0" y="0"/>
+          <a:chExt cx="0" cy="0"/>
+        </a:xfrm>
+      </p:grpSpPr>
+      <p:sp>
+        <p:nvSpPr>
+          <p:cNvPr id="223" name="Google Shape;223;g3fb6c4c2bd7_0_72:notes"/>
+          <p:cNvSpPr txBox="1"/>
+          <p:nvPr>
+            <p:ph idx="1" type="body"/>
+          </p:nvPr>
+        </p:nvSpPr>
+        <p:spPr>
+          <a:xfrm>
+            <a:off x="685800" y="4343400"/>
+            <a:ext cx="5486400" cy="4114800"/>
+          </a:xfrm>
+          <a:prstGeom prst="rect">
+            <a:avLst/>
+          </a:prstGeom>
+        </p:spPr>
+        <p:txBody>
+          <a:bodyPr anchorCtr="0" anchor="t" bIns="91425" lIns="91425" spcFirstLastPara="1" rIns="91425" wrap="square" tIns="91425">
+            <a:noAutofit/>
+          </a:bodyPr>
+          <a:lstStyle/>
+          <a:p>
+            <a:pPr indent="0" lvl="0" marL="0" rtl="0" algn="l">
+              <a:spcBef>
+                <a:spcPts val="0"/>
+              </a:spcBef>
+              <a:spcAft>
+                <a:spcPts val="0"/>
+              </a:spcAft>
+              <a:buNone/>
+            </a:pPr>
+            <a:r>
+              <a:t/>
+            </a:r>
+            <a:endParaRPr/>
+          </a:p>
+        </p:txBody>
+      </p:sp>
+      <p:sp>
+        <p:nvSpPr>
+          <p:cNvPr id="224" name="Google Shape;224;g3fb6c4c2bd7_0_72:notes"/>
+          <p:cNvSpPr/>
+          <p:nvPr>
+            <p:ph idx="2" type="sldImg"/>
+          </p:nvPr>
+        </p:nvSpPr>
+        <p:spPr>
+          <a:xfrm>
+            <a:off x="1143225" y="685800"/>
+            <a:ext cx="4572300" cy="3429000"/>
+          </a:xfrm>
+          <a:custGeom>
+            <a:rect b="b" l="l" r="r" t="t"/>
+            <a:pathLst>
+              <a:path extrusionOk="0" h="120000" w="120000">
+                <a:moveTo>
+                  <a:pt x="0" y="0"/>
+                </a:moveTo>
+                <a:lnTo>
+                  <a:pt x="120000" y="0"/>
+                </a:lnTo>
+                <a:lnTo>
+                  <a:pt x="120000" y="120000"/>
+                </a:lnTo>
+                <a:lnTo>
+                  <a:pt x="0" y="120000"/>
+                </a:lnTo>
+                <a:close/>
+              </a:path>
+            </a:pathLst>
+          </a:custGeom>
+        </p:spPr>
+      </p:sp>
+    </p:spTree>
+  </p:cSld>
+  <p:clrMapOvr>
+    <a:masterClrMapping/>
+  </p:clrMapOvr>
+</p:notes>
+</file>
+
 <file path=ppt/notesSlides/notesSlide2.xml><?xml version="1.0" encoding="utf-8"?>
 <p:notes xmlns:a="http://schemas.openxmlformats.org/drawingml/2006/main" xmlns:r="http://schemas.openxmlformats.org/officeDocument/2006/relationships" xmlns:mc="http://schemas.openxmlformats.org/markup-compatibility/2006" xmlns:mv="urn:schemas-microsoft-com:mac:vml" xmlns:p="http://schemas.openxmlformats.org/presentationml/2006/main" xmlns:c="http://schemas.openxmlformats.org/drawingml/2006/chart" xmlns:dgm="http://schemas.openxmlformats.org/drawingml/2006/diagram" xmlns:o="urn:schemas-microsoft-com:office:office" xmlns:v="urn:schemas-microsoft-com:vml" xmlns:pvml="urn:schemas-microsoft-com:office:powerpoint" xmlns:com="http://schemas.openxmlformats.org/drawingml/2006/compatibility" xmlns:p14="http://schemas.microsoft.com/office/powerpoint/2010/main" xmlns:p15="http://schemas.microsoft.com/office/powerpoint/2012/main" xmlns:ahyp="http://schemas.microsoft.com/office/drawing/2018/hyperlinkcolor" showMasterPhAnim="0" showMasterSp="0">
   <p:cSld>
@@ -1212,7 +1715,7 @@
   <p:cSld>
     <p:spTree>
       <p:nvGrpSpPr>
-        <p:cNvPr id="138" name="Shape 138"/>
+        <p:cNvPr id="139" name="Shape 139"/>
         <p:cNvGrpSpPr/>
         <p:nvPr/>
       </p:nvGrpSpPr>
@@ -1226,7 +1729,7 @@
       </p:grpSpPr>
       <p:sp>
         <p:nvSpPr>
-          <p:cNvPr id="139" name="Google Shape;139;p6:notes"/>
+          <p:cNvPr id="140" name="Google Shape;140;p6:notes"/>
           <p:cNvSpPr txBox="1"/>
           <p:nvPr>
             <p:ph idx="1" type="body"/>
@@ -1265,7 +1768,7 @@
       </p:sp>
       <p:sp>
         <p:nvSpPr>
-          <p:cNvPr id="140" name="Google Shape;140;p6:notes"/>
+          <p:cNvPr id="141" name="Google Shape;141;p6:notes"/>
           <p:cNvSpPr/>
           <p:nvPr>
             <p:ph idx="2" type="sldImg"/>
@@ -1275,6 +1778,303 @@
           <a:xfrm>
             <a:off x="1143225" y="685800"/>
             <a:ext cx="4572225" cy="3429000"/>
+          </a:xfrm>
+          <a:custGeom>
+            <a:rect b="b" l="l" r="r" t="t"/>
+            <a:pathLst>
+              <a:path extrusionOk="0" h="120000" w="120000">
+                <a:moveTo>
+                  <a:pt x="0" y="0"/>
+                </a:moveTo>
+                <a:lnTo>
+                  <a:pt x="120000" y="0"/>
+                </a:lnTo>
+                <a:lnTo>
+                  <a:pt x="120000" y="120000"/>
+                </a:lnTo>
+                <a:lnTo>
+                  <a:pt x="0" y="120000"/>
+                </a:lnTo>
+                <a:close/>
+              </a:path>
+            </a:pathLst>
+          </a:custGeom>
+        </p:spPr>
+      </p:sp>
+    </p:spTree>
+  </p:cSld>
+  <p:clrMapOvr>
+    <a:masterClrMapping/>
+  </p:clrMapOvr>
+</p:notes>
+</file>
+
+<file path=ppt/notesSlides/notesSlide7.xml><?xml version="1.0" encoding="utf-8"?>
+<p:notes xmlns:a="http://schemas.openxmlformats.org/drawingml/2006/main" xmlns:r="http://schemas.openxmlformats.org/officeDocument/2006/relationships" xmlns:mc="http://schemas.openxmlformats.org/markup-compatibility/2006" xmlns:mv="urn:schemas-microsoft-com:mac:vml" xmlns:p="http://schemas.openxmlformats.org/presentationml/2006/main" xmlns:c="http://schemas.openxmlformats.org/drawingml/2006/chart" xmlns:dgm="http://schemas.openxmlformats.org/drawingml/2006/diagram" xmlns:o="urn:schemas-microsoft-com:office:office" xmlns:v="urn:schemas-microsoft-com:vml" xmlns:pvml="urn:schemas-microsoft-com:office:powerpoint" xmlns:com="http://schemas.openxmlformats.org/drawingml/2006/compatibility" xmlns:p14="http://schemas.microsoft.com/office/powerpoint/2010/main" xmlns:p15="http://schemas.microsoft.com/office/powerpoint/2012/main" xmlns:ahyp="http://schemas.microsoft.com/office/drawing/2018/hyperlinkcolor" showMasterPhAnim="0" showMasterSp="0">
+  <p:cSld>
+    <p:spTree>
+      <p:nvGrpSpPr>
+        <p:cNvPr id="147" name="Shape 147"/>
+        <p:cNvGrpSpPr/>
+        <p:nvPr/>
+      </p:nvGrpSpPr>
+      <p:grpSpPr>
+        <a:xfrm>
+          <a:off x="0" y="0"/>
+          <a:ext cx="0" cy="0"/>
+          <a:chOff x="0" y="0"/>
+          <a:chExt cx="0" cy="0"/>
+        </a:xfrm>
+      </p:grpSpPr>
+      <p:sp>
+        <p:nvSpPr>
+          <p:cNvPr id="148" name="Google Shape;148;g3fb6c4c2bd7_0_0:notes"/>
+          <p:cNvSpPr txBox="1"/>
+          <p:nvPr>
+            <p:ph idx="1" type="body"/>
+          </p:nvPr>
+        </p:nvSpPr>
+        <p:spPr>
+          <a:xfrm>
+            <a:off x="685800" y="4343400"/>
+            <a:ext cx="5486400" cy="4114800"/>
+          </a:xfrm>
+          <a:prstGeom prst="rect">
+            <a:avLst/>
+          </a:prstGeom>
+        </p:spPr>
+        <p:txBody>
+          <a:bodyPr anchorCtr="0" anchor="t" bIns="91425" lIns="91425" spcFirstLastPara="1" rIns="91425" wrap="square" tIns="91425">
+            <a:noAutofit/>
+          </a:bodyPr>
+          <a:lstStyle/>
+          <a:p>
+            <a:pPr indent="0" lvl="0" marL="0" rtl="0" algn="l">
+              <a:spcBef>
+                <a:spcPts val="0"/>
+              </a:spcBef>
+              <a:spcAft>
+                <a:spcPts val="0"/>
+              </a:spcAft>
+              <a:buNone/>
+            </a:pPr>
+            <a:r>
+              <a:t/>
+            </a:r>
+            <a:endParaRPr/>
+          </a:p>
+        </p:txBody>
+      </p:sp>
+      <p:sp>
+        <p:nvSpPr>
+          <p:cNvPr id="149" name="Google Shape;149;g3fb6c4c2bd7_0_0:notes"/>
+          <p:cNvSpPr/>
+          <p:nvPr>
+            <p:ph idx="2" type="sldImg"/>
+          </p:nvPr>
+        </p:nvSpPr>
+        <p:spPr>
+          <a:xfrm>
+            <a:off x="1143225" y="685800"/>
+            <a:ext cx="4572300" cy="3429000"/>
+          </a:xfrm>
+          <a:custGeom>
+            <a:rect b="b" l="l" r="r" t="t"/>
+            <a:pathLst>
+              <a:path extrusionOk="0" h="120000" w="120000">
+                <a:moveTo>
+                  <a:pt x="0" y="0"/>
+                </a:moveTo>
+                <a:lnTo>
+                  <a:pt x="120000" y="0"/>
+                </a:lnTo>
+                <a:lnTo>
+                  <a:pt x="120000" y="120000"/>
+                </a:lnTo>
+                <a:lnTo>
+                  <a:pt x="0" y="120000"/>
+                </a:lnTo>
+                <a:close/>
+              </a:path>
+            </a:pathLst>
+          </a:custGeom>
+        </p:spPr>
+      </p:sp>
+    </p:spTree>
+  </p:cSld>
+  <p:clrMapOvr>
+    <a:masterClrMapping/>
+  </p:clrMapOvr>
+</p:notes>
+</file>
+
+<file path=ppt/notesSlides/notesSlide8.xml><?xml version="1.0" encoding="utf-8"?>
+<p:notes xmlns:a="http://schemas.openxmlformats.org/drawingml/2006/main" xmlns:r="http://schemas.openxmlformats.org/officeDocument/2006/relationships" xmlns:mc="http://schemas.openxmlformats.org/markup-compatibility/2006" xmlns:mv="urn:schemas-microsoft-com:mac:vml" xmlns:p="http://schemas.openxmlformats.org/presentationml/2006/main" xmlns:c="http://schemas.openxmlformats.org/drawingml/2006/chart" xmlns:dgm="http://schemas.openxmlformats.org/drawingml/2006/diagram" xmlns:o="urn:schemas-microsoft-com:office:office" xmlns:v="urn:schemas-microsoft-com:vml" xmlns:pvml="urn:schemas-microsoft-com:office:powerpoint" xmlns:com="http://schemas.openxmlformats.org/drawingml/2006/compatibility" xmlns:p14="http://schemas.microsoft.com/office/powerpoint/2010/main" xmlns:p15="http://schemas.microsoft.com/office/powerpoint/2012/main" xmlns:ahyp="http://schemas.microsoft.com/office/drawing/2018/hyperlinkcolor" showMasterPhAnim="0" showMasterSp="0">
+  <p:cSld>
+    <p:spTree>
+      <p:nvGrpSpPr>
+        <p:cNvPr id="154" name="Shape 154"/>
+        <p:cNvGrpSpPr/>
+        <p:nvPr/>
+      </p:nvGrpSpPr>
+      <p:grpSpPr>
+        <a:xfrm>
+          <a:off x="0" y="0"/>
+          <a:ext cx="0" cy="0"/>
+          <a:chOff x="0" y="0"/>
+          <a:chExt cx="0" cy="0"/>
+        </a:xfrm>
+      </p:grpSpPr>
+      <p:sp>
+        <p:nvSpPr>
+          <p:cNvPr id="155" name="Google Shape;155;g3fb6c4c2bd7_0_6:notes"/>
+          <p:cNvSpPr txBox="1"/>
+          <p:nvPr>
+            <p:ph idx="1" type="body"/>
+          </p:nvPr>
+        </p:nvSpPr>
+        <p:spPr>
+          <a:xfrm>
+            <a:off x="685800" y="4343400"/>
+            <a:ext cx="5486400" cy="4114800"/>
+          </a:xfrm>
+          <a:prstGeom prst="rect">
+            <a:avLst/>
+          </a:prstGeom>
+        </p:spPr>
+        <p:txBody>
+          <a:bodyPr anchorCtr="0" anchor="t" bIns="91425" lIns="91425" spcFirstLastPara="1" rIns="91425" wrap="square" tIns="91425">
+            <a:noAutofit/>
+          </a:bodyPr>
+          <a:lstStyle/>
+          <a:p>
+            <a:pPr indent="0" lvl="0" marL="0" rtl="0" algn="l">
+              <a:spcBef>
+                <a:spcPts val="0"/>
+              </a:spcBef>
+              <a:spcAft>
+                <a:spcPts val="0"/>
+              </a:spcAft>
+              <a:buNone/>
+            </a:pPr>
+            <a:r>
+              <a:t/>
+            </a:r>
+            <a:endParaRPr/>
+          </a:p>
+        </p:txBody>
+      </p:sp>
+      <p:sp>
+        <p:nvSpPr>
+          <p:cNvPr id="156" name="Google Shape;156;g3fb6c4c2bd7_0_6:notes"/>
+          <p:cNvSpPr/>
+          <p:nvPr>
+            <p:ph idx="2" type="sldImg"/>
+          </p:nvPr>
+        </p:nvSpPr>
+        <p:spPr>
+          <a:xfrm>
+            <a:off x="1143225" y="685800"/>
+            <a:ext cx="4572300" cy="3429000"/>
+          </a:xfrm>
+          <a:custGeom>
+            <a:rect b="b" l="l" r="r" t="t"/>
+            <a:pathLst>
+              <a:path extrusionOk="0" h="120000" w="120000">
+                <a:moveTo>
+                  <a:pt x="0" y="0"/>
+                </a:moveTo>
+                <a:lnTo>
+                  <a:pt x="120000" y="0"/>
+                </a:lnTo>
+                <a:lnTo>
+                  <a:pt x="120000" y="120000"/>
+                </a:lnTo>
+                <a:lnTo>
+                  <a:pt x="0" y="120000"/>
+                </a:lnTo>
+                <a:close/>
+              </a:path>
+            </a:pathLst>
+          </a:custGeom>
+        </p:spPr>
+      </p:sp>
+    </p:spTree>
+  </p:cSld>
+  <p:clrMapOvr>
+    <a:masterClrMapping/>
+  </p:clrMapOvr>
+</p:notes>
+</file>
+
+<file path=ppt/notesSlides/notesSlide9.xml><?xml version="1.0" encoding="utf-8"?>
+<p:notes xmlns:a="http://schemas.openxmlformats.org/drawingml/2006/main" xmlns:r="http://schemas.openxmlformats.org/officeDocument/2006/relationships" xmlns:mc="http://schemas.openxmlformats.org/markup-compatibility/2006" xmlns:mv="urn:schemas-microsoft-com:mac:vml" xmlns:p="http://schemas.openxmlformats.org/presentationml/2006/main" xmlns:c="http://schemas.openxmlformats.org/drawingml/2006/chart" xmlns:dgm="http://schemas.openxmlformats.org/drawingml/2006/diagram" xmlns:o="urn:schemas-microsoft-com:office:office" xmlns:v="urn:schemas-microsoft-com:vml" xmlns:pvml="urn:schemas-microsoft-com:office:powerpoint" xmlns:com="http://schemas.openxmlformats.org/drawingml/2006/compatibility" xmlns:p14="http://schemas.microsoft.com/office/powerpoint/2010/main" xmlns:p15="http://schemas.microsoft.com/office/powerpoint/2012/main" xmlns:ahyp="http://schemas.microsoft.com/office/drawing/2018/hyperlinkcolor" showMasterPhAnim="0" showMasterSp="0">
+  <p:cSld>
+    <p:spTree>
+      <p:nvGrpSpPr>
+        <p:cNvPr id="167" name="Shape 167"/>
+        <p:cNvGrpSpPr/>
+        <p:nvPr/>
+      </p:nvGrpSpPr>
+      <p:grpSpPr>
+        <a:xfrm>
+          <a:off x="0" y="0"/>
+          <a:ext cx="0" cy="0"/>
+          <a:chOff x="0" y="0"/>
+          <a:chExt cx="0" cy="0"/>
+        </a:xfrm>
+      </p:grpSpPr>
+      <p:sp>
+        <p:nvSpPr>
+          <p:cNvPr id="168" name="Google Shape;168;g3fb6c4c2bd7_0_18:notes"/>
+          <p:cNvSpPr txBox="1"/>
+          <p:nvPr>
+            <p:ph idx="1" type="body"/>
+          </p:nvPr>
+        </p:nvSpPr>
+        <p:spPr>
+          <a:xfrm>
+            <a:off x="685800" y="4343400"/>
+            <a:ext cx="5486400" cy="4114800"/>
+          </a:xfrm>
+          <a:prstGeom prst="rect">
+            <a:avLst/>
+          </a:prstGeom>
+        </p:spPr>
+        <p:txBody>
+          <a:bodyPr anchorCtr="0" anchor="t" bIns="91425" lIns="91425" spcFirstLastPara="1" rIns="91425" wrap="square" tIns="91425">
+            <a:noAutofit/>
+          </a:bodyPr>
+          <a:lstStyle/>
+          <a:p>
+            <a:pPr indent="0" lvl="0" marL="0" rtl="0" algn="l">
+              <a:spcBef>
+                <a:spcPts val="0"/>
+              </a:spcBef>
+              <a:spcAft>
+                <a:spcPts val="0"/>
+              </a:spcAft>
+              <a:buNone/>
+            </a:pPr>
+            <a:r>
+              <a:t/>
+            </a:r>
+            <a:endParaRPr/>
+          </a:p>
+        </p:txBody>
+      </p:sp>
+      <p:sp>
+        <p:nvSpPr>
+          <p:cNvPr id="169" name="Google Shape;169;g3fb6c4c2bd7_0_18:notes"/>
+          <p:cNvSpPr/>
+          <p:nvPr>
+            <p:ph idx="2" type="sldImg"/>
+          </p:nvPr>
+        </p:nvSpPr>
+        <p:spPr>
+          <a:xfrm>
+            <a:off x="1143225" y="685800"/>
+            <a:ext cx="4572300" cy="3429000"/>
           </a:xfrm>
           <a:custGeom>
             <a:rect b="b" l="l" r="r" t="t"/>
@@ -11110,9 +11910,1764 @@
                 <a:cs typeface="Inter"/>
                 <a:sym typeface="Inter"/>
               </a:rPr>
-              <a:t>DEEP PURGE</a:t>
+              <a:t>Introduction &amp; DEEP PURGE</a:t>
             </a:r>
             <a:endParaRPr/>
+          </a:p>
+        </p:txBody>
+      </p:sp>
+    </p:spTree>
+  </p:cSld>
+  <p:clrMapOvr>
+    <a:masterClrMapping/>
+  </p:clrMapOvr>
+</p:sld>
+</file>
+
+<file path=ppt/slides/slide10.xml><?xml version="1.0" encoding="utf-8"?>
+<p:sld xmlns:a="http://schemas.openxmlformats.org/drawingml/2006/main" xmlns:r="http://schemas.openxmlformats.org/officeDocument/2006/relationships" xmlns:mc="http://schemas.openxmlformats.org/markup-compatibility/2006" xmlns:mv="urn:schemas-microsoft-com:mac:vml" xmlns:p="http://schemas.openxmlformats.org/presentationml/2006/main" xmlns:c="http://schemas.openxmlformats.org/drawingml/2006/chart" xmlns:dgm="http://schemas.openxmlformats.org/drawingml/2006/diagram" xmlns:o="urn:schemas-microsoft-com:office:office" xmlns:v="urn:schemas-microsoft-com:vml" xmlns:pvml="urn:schemas-microsoft-com:office:powerpoint" xmlns:com="http://schemas.openxmlformats.org/drawingml/2006/compatibility" xmlns:p14="http://schemas.microsoft.com/office/powerpoint/2010/main" xmlns:p15="http://schemas.microsoft.com/office/powerpoint/2012/main" xmlns:ahyp="http://schemas.microsoft.com/office/drawing/2018/hyperlinkcolor">
+  <p:cSld>
+    <p:bg>
+      <p:bgPr>
+        <a:solidFill>
+          <a:srgbClr val="1A1D21"/>
+        </a:solidFill>
+      </p:bgPr>
+    </p:bg>
+    <p:spTree>
+      <p:nvGrpSpPr>
+        <p:cNvPr id="188" name="Shape 188"/>
+        <p:cNvGrpSpPr/>
+        <p:nvPr/>
+      </p:nvGrpSpPr>
+      <p:grpSpPr>
+        <a:xfrm>
+          <a:off x="0" y="0"/>
+          <a:ext cx="0" cy="0"/>
+          <a:chOff x="0" y="0"/>
+          <a:chExt cx="0" cy="0"/>
+        </a:xfrm>
+      </p:grpSpPr>
+      <p:pic>
+        <p:nvPicPr>
+          <p:cNvPr descr="image.png" id="189" name="Google Shape;189;p22"/>
+          <p:cNvPicPr preferRelativeResize="0"/>
+          <p:nvPr/>
+        </p:nvPicPr>
+        <p:blipFill rotWithShape="1">
+          <a:blip r:embed="rId3">
+            <a:alphaModFix/>
+          </a:blip>
+          <a:srcRect b="0" l="0" r="0" t="0"/>
+          <a:stretch/>
+        </p:blipFill>
+        <p:spPr>
+          <a:xfrm>
+            <a:off x="0" y="0"/>
+            <a:ext cx="12192000" cy="6858000"/>
+          </a:xfrm>
+          <a:prstGeom prst="rect">
+            <a:avLst/>
+          </a:prstGeom>
+          <a:noFill/>
+          <a:ln>
+            <a:noFill/>
+          </a:ln>
+        </p:spPr>
+      </p:pic>
+      <p:sp>
+        <p:nvSpPr>
+          <p:cNvPr id="190" name="Google Shape;190;p22"/>
+          <p:cNvSpPr txBox="1"/>
+          <p:nvPr/>
+        </p:nvSpPr>
+        <p:spPr>
+          <a:xfrm>
+            <a:off x="581025" y="2971800"/>
+            <a:ext cx="5277000" cy="1731600"/>
+          </a:xfrm>
+          <a:prstGeom prst="rect">
+            <a:avLst/>
+          </a:prstGeom>
+          <a:noFill/>
+          <a:ln>
+            <a:noFill/>
+          </a:ln>
+        </p:spPr>
+        <p:txBody>
+          <a:bodyPr anchorCtr="0" anchor="t" bIns="0" lIns="0" spcFirstLastPara="1" rIns="0" wrap="square" tIns="0">
+            <a:spAutoFit/>
+          </a:bodyPr>
+          <a:lstStyle/>
+          <a:p>
+            <a:pPr indent="0" lvl="0" marL="0" marR="0" rtl="0" algn="l">
+              <a:lnSpc>
+                <a:spcPct val="100000"/>
+              </a:lnSpc>
+              <a:spcBef>
+                <a:spcPts val="0"/>
+              </a:spcBef>
+              <a:spcAft>
+                <a:spcPts val="0"/>
+              </a:spcAft>
+              <a:buNone/>
+            </a:pPr>
+            <a:r>
+              <a:rPr lang="en-US" sz="11250">
+                <a:solidFill>
+                  <a:srgbClr val="71C238"/>
+                </a:solidFill>
+                <a:latin typeface="Inter ExtraBold"/>
+                <a:ea typeface="Inter ExtraBold"/>
+                <a:cs typeface="Inter ExtraBold"/>
+                <a:sym typeface="Inter ExtraBold"/>
+              </a:rPr>
+              <a:t>90</a:t>
+            </a:r>
+            <a:r>
+              <a:rPr b="0" i="0" lang="en-US" sz="11250" u="none" cap="none" strike="noStrike">
+                <a:solidFill>
+                  <a:srgbClr val="71C238"/>
+                </a:solidFill>
+                <a:latin typeface="Inter ExtraBold"/>
+                <a:ea typeface="Inter ExtraBold"/>
+                <a:cs typeface="Inter ExtraBold"/>
+                <a:sym typeface="Inter ExtraBold"/>
+              </a:rPr>
+              <a:t>%</a:t>
+            </a:r>
+            <a:endParaRPr/>
+          </a:p>
+        </p:txBody>
+      </p:sp>
+      <p:sp>
+        <p:nvSpPr>
+          <p:cNvPr id="191" name="Google Shape;191;p22"/>
+          <p:cNvSpPr txBox="1"/>
+          <p:nvPr/>
+        </p:nvSpPr>
+        <p:spPr>
+          <a:xfrm>
+            <a:off x="581025" y="4495800"/>
+            <a:ext cx="5421600" cy="300300"/>
+          </a:xfrm>
+          <a:prstGeom prst="rect">
+            <a:avLst/>
+          </a:prstGeom>
+          <a:noFill/>
+          <a:ln>
+            <a:noFill/>
+          </a:ln>
+        </p:spPr>
+        <p:txBody>
+          <a:bodyPr anchorCtr="0" anchor="t" bIns="0" lIns="0" spcFirstLastPara="1" rIns="0" wrap="square" tIns="0">
+            <a:spAutoFit/>
+          </a:bodyPr>
+          <a:lstStyle/>
+          <a:p>
+            <a:pPr indent="0" lvl="0" marL="0" marR="0" rtl="0" algn="l">
+              <a:spcBef>
+                <a:spcPts val="0"/>
+              </a:spcBef>
+              <a:spcAft>
+                <a:spcPts val="0"/>
+              </a:spcAft>
+              <a:buNone/>
+            </a:pPr>
+            <a:r>
+              <a:rPr lang="en-US" sz="1950">
+                <a:solidFill>
+                  <a:srgbClr val="FFFFFF"/>
+                </a:solidFill>
+                <a:latin typeface="Inter SemiBold"/>
+                <a:ea typeface="Inter SemiBold"/>
+                <a:cs typeface="Inter SemiBold"/>
+                <a:sym typeface="Inter SemiBold"/>
+              </a:rPr>
+              <a:t>Team </a:t>
+            </a:r>
+            <a:r>
+              <a:rPr lang="en-US" sz="1950">
+                <a:solidFill>
+                  <a:srgbClr val="FFFFFF"/>
+                </a:solidFill>
+                <a:latin typeface="Inter SemiBold"/>
+                <a:ea typeface="Inter SemiBold"/>
+                <a:cs typeface="Inter SemiBold"/>
+                <a:sym typeface="Inter SemiBold"/>
+              </a:rPr>
+              <a:t>awareness</a:t>
+            </a:r>
+            <a:r>
+              <a:rPr lang="en-US" sz="1950">
+                <a:solidFill>
+                  <a:srgbClr val="FFFFFF"/>
+                </a:solidFill>
+                <a:latin typeface="Inter SemiBold"/>
+                <a:ea typeface="Inter SemiBold"/>
+                <a:cs typeface="Inter SemiBold"/>
+                <a:sym typeface="Inter SemiBold"/>
+              </a:rPr>
+              <a:t> about the coordination view</a:t>
+            </a:r>
+            <a:endParaRPr/>
+          </a:p>
+        </p:txBody>
+      </p:sp>
+      <p:sp>
+        <p:nvSpPr>
+          <p:cNvPr id="192" name="Google Shape;192;p22"/>
+          <p:cNvSpPr txBox="1"/>
+          <p:nvPr/>
+        </p:nvSpPr>
+        <p:spPr>
+          <a:xfrm>
+            <a:off x="6002620" y="2781300"/>
+            <a:ext cx="6256200" cy="346200"/>
+          </a:xfrm>
+          <a:prstGeom prst="rect">
+            <a:avLst/>
+          </a:prstGeom>
+          <a:noFill/>
+          <a:ln>
+            <a:noFill/>
+          </a:ln>
+        </p:spPr>
+        <p:txBody>
+          <a:bodyPr anchorCtr="0" anchor="t" bIns="0" lIns="0" spcFirstLastPara="1" rIns="0" wrap="square" tIns="0">
+            <a:spAutoFit/>
+          </a:bodyPr>
+          <a:lstStyle/>
+          <a:p>
+            <a:pPr indent="0" lvl="0" marL="0" marR="0" rtl="0" algn="l">
+              <a:spcBef>
+                <a:spcPts val="0"/>
+              </a:spcBef>
+              <a:spcAft>
+                <a:spcPts val="0"/>
+              </a:spcAft>
+              <a:buNone/>
+            </a:pPr>
+            <a:r>
+              <a:rPr b="0" i="0" lang="en-US" sz="2250" u="none" cap="none" strike="noStrike">
+                <a:solidFill>
+                  <a:srgbClr val="FFFFFF"/>
+                </a:solidFill>
+                <a:latin typeface="Inter SemiBold"/>
+                <a:ea typeface="Inter SemiBold"/>
+                <a:cs typeface="Inter SemiBold"/>
+                <a:sym typeface="Inter SemiBold"/>
+              </a:rPr>
+              <a:t>Focus on Coordination, Not </a:t>
+            </a:r>
+            <a:r>
+              <a:rPr lang="en-US" sz="2250">
+                <a:solidFill>
+                  <a:srgbClr val="FFFFFF"/>
+                </a:solidFill>
+                <a:latin typeface="Inter SemiBold"/>
+                <a:ea typeface="Inter SemiBold"/>
+                <a:cs typeface="Inter SemiBold"/>
+                <a:sym typeface="Inter SemiBold"/>
+              </a:rPr>
+              <a:t>Repetitive Tasks</a:t>
+            </a:r>
+            <a:endParaRPr/>
+          </a:p>
+        </p:txBody>
+      </p:sp>
+      <p:sp>
+        <p:nvSpPr>
+          <p:cNvPr id="193" name="Google Shape;193;p22"/>
+          <p:cNvSpPr txBox="1"/>
+          <p:nvPr/>
+        </p:nvSpPr>
+        <p:spPr>
+          <a:xfrm>
+            <a:off x="6002620" y="3267075"/>
+            <a:ext cx="5277000" cy="1015800"/>
+          </a:xfrm>
+          <a:prstGeom prst="rect">
+            <a:avLst/>
+          </a:prstGeom>
+          <a:noFill/>
+          <a:ln>
+            <a:noFill/>
+          </a:ln>
+        </p:spPr>
+        <p:txBody>
+          <a:bodyPr anchorCtr="0" anchor="t" bIns="0" lIns="0" spcFirstLastPara="1" rIns="0" wrap="square" tIns="0">
+            <a:spAutoFit/>
+          </a:bodyPr>
+          <a:lstStyle/>
+          <a:p>
+            <a:pPr indent="0" lvl="0" marL="0" marR="0" rtl="0" algn="l">
+              <a:lnSpc>
+                <a:spcPct val="150000"/>
+              </a:lnSpc>
+              <a:spcBef>
+                <a:spcPts val="0"/>
+              </a:spcBef>
+              <a:spcAft>
+                <a:spcPts val="0"/>
+              </a:spcAft>
+              <a:buNone/>
+            </a:pPr>
+            <a:r>
+              <a:rPr lang="en-US" sz="1650">
+                <a:solidFill>
+                  <a:srgbClr val="B5BAC1"/>
+                </a:solidFill>
+                <a:latin typeface="Inter"/>
+                <a:ea typeface="Inter"/>
+                <a:cs typeface="Inter"/>
+                <a:sym typeface="Inter"/>
+              </a:rPr>
+              <a:t>by simply hitting this run button in dynamo you do not have to worry about how your view getting adjusted</a:t>
+            </a:r>
+            <a:endParaRPr/>
+          </a:p>
+        </p:txBody>
+      </p:sp>
+      <p:sp>
+        <p:nvSpPr>
+          <p:cNvPr id="194" name="Google Shape;194;p22"/>
+          <p:cNvSpPr txBox="1"/>
+          <p:nvPr/>
+        </p:nvSpPr>
+        <p:spPr>
+          <a:xfrm>
+            <a:off x="581025" y="581025"/>
+            <a:ext cx="11581500" cy="519600"/>
+          </a:xfrm>
+          <a:prstGeom prst="rect">
+            <a:avLst/>
+          </a:prstGeom>
+          <a:noFill/>
+          <a:ln>
+            <a:noFill/>
+          </a:ln>
+        </p:spPr>
+        <p:txBody>
+          <a:bodyPr anchorCtr="0" anchor="t" bIns="0" lIns="0" spcFirstLastPara="1" rIns="0" wrap="square" tIns="0">
+            <a:spAutoFit/>
+          </a:bodyPr>
+          <a:lstStyle/>
+          <a:p>
+            <a:pPr indent="0" lvl="0" marL="0" marR="0" rtl="0" algn="l">
+              <a:spcBef>
+                <a:spcPts val="0"/>
+              </a:spcBef>
+              <a:spcAft>
+                <a:spcPts val="0"/>
+              </a:spcAft>
+              <a:buNone/>
+            </a:pPr>
+            <a:r>
+              <a:rPr b="0" i="0" lang="en-US" sz="3375" u="none" cap="none" strike="noStrike">
+                <a:solidFill>
+                  <a:srgbClr val="FFFFFF"/>
+                </a:solidFill>
+                <a:latin typeface="Inter ExtraBold"/>
+                <a:ea typeface="Inter ExtraBold"/>
+                <a:cs typeface="Inter ExtraBold"/>
+                <a:sym typeface="Inter ExtraBold"/>
+              </a:rPr>
+              <a:t>Coordination </a:t>
+            </a:r>
+            <a:r>
+              <a:rPr b="0" i="0" lang="en-US" sz="3375" u="none" cap="none" strike="noStrike">
+                <a:solidFill>
+                  <a:srgbClr val="0696D7"/>
+                </a:solidFill>
+                <a:latin typeface="Inter ExtraBold"/>
+                <a:ea typeface="Inter ExtraBold"/>
+                <a:cs typeface="Inter ExtraBold"/>
+                <a:sym typeface="Inter ExtraBold"/>
+              </a:rPr>
+              <a:t>Impact</a:t>
+            </a:r>
+            <a:endParaRPr/>
+          </a:p>
+        </p:txBody>
+      </p:sp>
+    </p:spTree>
+  </p:cSld>
+  <p:clrMapOvr>
+    <a:masterClrMapping/>
+  </p:clrMapOvr>
+</p:sld>
+</file>
+
+<file path=ppt/slides/slide11.xml><?xml version="1.0" encoding="utf-8"?>
+<p:sld xmlns:a="http://schemas.openxmlformats.org/drawingml/2006/main" xmlns:r="http://schemas.openxmlformats.org/officeDocument/2006/relationships" xmlns:mc="http://schemas.openxmlformats.org/markup-compatibility/2006" xmlns:mv="urn:schemas-microsoft-com:mac:vml" xmlns:p="http://schemas.openxmlformats.org/presentationml/2006/main" xmlns:c="http://schemas.openxmlformats.org/drawingml/2006/chart" xmlns:dgm="http://schemas.openxmlformats.org/drawingml/2006/diagram" xmlns:o="urn:schemas-microsoft-com:office:office" xmlns:v="urn:schemas-microsoft-com:vml" xmlns:pvml="urn:schemas-microsoft-com:office:powerpoint" xmlns:com="http://schemas.openxmlformats.org/drawingml/2006/compatibility" xmlns:p14="http://schemas.microsoft.com/office/powerpoint/2010/main" xmlns:p15="http://schemas.microsoft.com/office/powerpoint/2012/main" xmlns:ahyp="http://schemas.microsoft.com/office/drawing/2018/hyperlinkcolor">
+  <p:cSld>
+    <p:bg>
+      <p:bgPr>
+        <a:solidFill>
+          <a:srgbClr val="1A1D21"/>
+        </a:solidFill>
+      </p:bgPr>
+    </p:bg>
+    <p:spTree>
+      <p:nvGrpSpPr>
+        <p:cNvPr id="198" name="Shape 198"/>
+        <p:cNvGrpSpPr/>
+        <p:nvPr/>
+      </p:nvGrpSpPr>
+      <p:grpSpPr>
+        <a:xfrm>
+          <a:off x="0" y="0"/>
+          <a:ext cx="0" cy="0"/>
+          <a:chOff x="0" y="0"/>
+          <a:chExt cx="0" cy="0"/>
+        </a:xfrm>
+      </p:grpSpPr>
+      <p:pic>
+        <p:nvPicPr>
+          <p:cNvPr descr="image.png" id="199" name="Google Shape;199;p23"/>
+          <p:cNvPicPr preferRelativeResize="0"/>
+          <p:nvPr/>
+        </p:nvPicPr>
+        <p:blipFill rotWithShape="1">
+          <a:blip r:embed="rId3">
+            <a:alphaModFix/>
+          </a:blip>
+          <a:srcRect b="0" l="0" r="0" t="0"/>
+          <a:stretch/>
+        </p:blipFill>
+        <p:spPr>
+          <a:xfrm>
+            <a:off x="75" y="212275"/>
+            <a:ext cx="12192000" cy="6858000"/>
+          </a:xfrm>
+          <a:prstGeom prst="rect">
+            <a:avLst/>
+          </a:prstGeom>
+          <a:noFill/>
+          <a:ln>
+            <a:noFill/>
+          </a:ln>
+        </p:spPr>
+      </p:pic>
+      <p:sp>
+        <p:nvSpPr>
+          <p:cNvPr id="200" name="Google Shape;200;p23"/>
+          <p:cNvSpPr txBox="1"/>
+          <p:nvPr/>
+        </p:nvSpPr>
+        <p:spPr>
+          <a:xfrm>
+            <a:off x="305276" y="2171700"/>
+            <a:ext cx="11581500" cy="808200"/>
+          </a:xfrm>
+          <a:prstGeom prst="rect">
+            <a:avLst/>
+          </a:prstGeom>
+          <a:noFill/>
+          <a:ln>
+            <a:noFill/>
+          </a:ln>
+        </p:spPr>
+        <p:txBody>
+          <a:bodyPr anchorCtr="0" anchor="t" bIns="0" lIns="0" spcFirstLastPara="1" rIns="0" wrap="square" tIns="0">
+            <a:spAutoFit/>
+          </a:bodyPr>
+          <a:lstStyle/>
+          <a:p>
+            <a:pPr indent="0" lvl="0" marL="0" marR="0" rtl="0" algn="ctr">
+              <a:spcBef>
+                <a:spcPts val="0"/>
+              </a:spcBef>
+              <a:spcAft>
+                <a:spcPts val="0"/>
+              </a:spcAft>
+              <a:buNone/>
+            </a:pPr>
+            <a:r>
+              <a:rPr b="0" i="0" lang="en-US" sz="5250" u="none" cap="none" strike="noStrike">
+                <a:solidFill>
+                  <a:srgbClr val="FFFFFF"/>
+                </a:solidFill>
+                <a:latin typeface="Inter ExtraBold"/>
+                <a:ea typeface="Inter ExtraBold"/>
+                <a:cs typeface="Inter ExtraBold"/>
+                <a:sym typeface="Inter ExtraBold"/>
+              </a:rPr>
+              <a:t>Grab the </a:t>
+            </a:r>
+            <a:r>
+              <a:rPr b="0" i="0" lang="en-US" sz="5250" u="none" cap="none" strike="noStrike">
+                <a:solidFill>
+                  <a:srgbClr val="71C238"/>
+                </a:solidFill>
+                <a:latin typeface="Inter ExtraBold"/>
+                <a:ea typeface="Inter ExtraBold"/>
+                <a:cs typeface="Inter ExtraBold"/>
+                <a:sym typeface="Inter ExtraBold"/>
+              </a:rPr>
+              <a:t>Workflow</a:t>
+            </a:r>
+            <a:endParaRPr/>
+          </a:p>
+        </p:txBody>
+      </p:sp>
+      <p:sp>
+        <p:nvSpPr>
+          <p:cNvPr id="201" name="Google Shape;201;p23"/>
+          <p:cNvSpPr txBox="1"/>
+          <p:nvPr/>
+        </p:nvSpPr>
+        <p:spPr>
+          <a:xfrm>
+            <a:off x="581025" y="3171825"/>
+            <a:ext cx="11030100" cy="254100"/>
+          </a:xfrm>
+          <a:prstGeom prst="rect">
+            <a:avLst/>
+          </a:prstGeom>
+          <a:noFill/>
+          <a:ln>
+            <a:noFill/>
+          </a:ln>
+        </p:spPr>
+        <p:txBody>
+          <a:bodyPr anchorCtr="0" anchor="t" bIns="0" lIns="0" spcFirstLastPara="1" rIns="0" wrap="square" tIns="0">
+            <a:spAutoFit/>
+          </a:bodyPr>
+          <a:lstStyle/>
+          <a:p>
+            <a:pPr indent="0" lvl="0" marL="0" marR="0" rtl="0" algn="ctr">
+              <a:lnSpc>
+                <a:spcPct val="150000"/>
+              </a:lnSpc>
+              <a:spcBef>
+                <a:spcPts val="0"/>
+              </a:spcBef>
+              <a:spcAft>
+                <a:spcPts val="0"/>
+              </a:spcAft>
+              <a:buNone/>
+            </a:pPr>
+            <a:r>
+              <a:rPr b="0" i="0" lang="en-US" sz="1650" u="none" cap="none" strike="noStrike">
+                <a:solidFill>
+                  <a:srgbClr val="B5BAC1"/>
+                </a:solidFill>
+                <a:latin typeface="Inter"/>
+                <a:ea typeface="Inter"/>
+                <a:cs typeface="Inter"/>
+                <a:sym typeface="Inter"/>
+              </a:rPr>
+              <a:t>Download the Dynamo </a:t>
+            </a:r>
+            <a:r>
+              <a:rPr lang="en-US" sz="1650">
+                <a:solidFill>
+                  <a:srgbClr val="B5BAC1"/>
+                </a:solidFill>
+                <a:latin typeface="Inter"/>
+                <a:ea typeface="Inter"/>
+                <a:cs typeface="Inter"/>
+                <a:sym typeface="Inter"/>
+              </a:rPr>
+              <a:t>script</a:t>
+            </a:r>
+            <a:r>
+              <a:rPr b="0" i="0" lang="en-US" sz="1650" u="none" cap="none" strike="noStrike">
+                <a:solidFill>
+                  <a:srgbClr val="B5BAC1"/>
+                </a:solidFill>
+                <a:latin typeface="Inter"/>
+                <a:ea typeface="Inter"/>
+                <a:cs typeface="Inter"/>
+                <a:sym typeface="Inter"/>
+              </a:rPr>
+              <a:t> and the </a:t>
+            </a:r>
+            <a:r>
+              <a:rPr lang="en-US" sz="1650">
+                <a:solidFill>
+                  <a:srgbClr val="B5BAC1"/>
+                </a:solidFill>
+                <a:latin typeface="Inter"/>
+                <a:ea typeface="Inter"/>
+                <a:cs typeface="Inter"/>
+                <a:sym typeface="Inter"/>
+              </a:rPr>
+              <a:t>Presentation</a:t>
+            </a:r>
+            <a:r>
+              <a:rPr b="0" i="0" lang="en-US" sz="1650" u="none" cap="none" strike="noStrike">
+                <a:solidFill>
+                  <a:srgbClr val="B5BAC1"/>
+                </a:solidFill>
+                <a:latin typeface="Inter"/>
+                <a:ea typeface="Inter"/>
+                <a:cs typeface="Inter"/>
+                <a:sym typeface="Inter"/>
+              </a:rPr>
+              <a:t> for this episode.</a:t>
+            </a:r>
+            <a:endParaRPr/>
+          </a:p>
+        </p:txBody>
+      </p:sp>
+      <p:pic>
+        <p:nvPicPr>
+          <p:cNvPr descr="image.png" id="202" name="Google Shape;202;p23"/>
+          <p:cNvPicPr preferRelativeResize="0"/>
+          <p:nvPr/>
+        </p:nvPicPr>
+        <p:blipFill rotWithShape="1">
+          <a:blip r:embed="rId4">
+            <a:alphaModFix/>
+          </a:blip>
+          <a:srcRect b="0" l="0" r="0" t="0"/>
+          <a:stretch/>
+        </p:blipFill>
+        <p:spPr>
+          <a:xfrm>
+            <a:off x="3739016" y="5177046"/>
+            <a:ext cx="219075" cy="228600"/>
+          </a:xfrm>
+          <a:prstGeom prst="rect">
+            <a:avLst/>
+          </a:prstGeom>
+          <a:noFill/>
+          <a:ln>
+            <a:noFill/>
+          </a:ln>
+        </p:spPr>
+      </p:pic>
+      <p:pic>
+        <p:nvPicPr>
+          <p:cNvPr id="203" name="Google Shape;203;p23"/>
+          <p:cNvPicPr preferRelativeResize="0"/>
+          <p:nvPr/>
+        </p:nvPicPr>
+        <p:blipFill>
+          <a:blip r:embed="rId5">
+            <a:alphaModFix/>
+          </a:blip>
+          <a:stretch>
+            <a:fillRect/>
+          </a:stretch>
+        </p:blipFill>
+        <p:spPr>
+          <a:xfrm>
+            <a:off x="3739028" y="4700771"/>
+            <a:ext cx="219075" cy="218535"/>
+          </a:xfrm>
+          <a:prstGeom prst="rect">
+            <a:avLst/>
+          </a:prstGeom>
+          <a:noFill/>
+          <a:ln>
+            <a:noFill/>
+          </a:ln>
+        </p:spPr>
+      </p:pic>
+      <p:sp>
+        <p:nvSpPr>
+          <p:cNvPr id="204" name="Google Shape;204;p23"/>
+          <p:cNvSpPr txBox="1"/>
+          <p:nvPr/>
+        </p:nvSpPr>
+        <p:spPr>
+          <a:xfrm>
+            <a:off x="4077345" y="4718550"/>
+            <a:ext cx="4375800" cy="254100"/>
+          </a:xfrm>
+          <a:prstGeom prst="rect">
+            <a:avLst/>
+          </a:prstGeom>
+          <a:noFill/>
+          <a:ln>
+            <a:noFill/>
+          </a:ln>
+        </p:spPr>
+        <p:txBody>
+          <a:bodyPr anchorCtr="0" anchor="t" bIns="0" lIns="0" spcFirstLastPara="1" rIns="0" wrap="square" tIns="0">
+            <a:spAutoFit/>
+          </a:bodyPr>
+          <a:lstStyle/>
+          <a:p>
+            <a:pPr indent="0" lvl="0" marL="0" marR="0" rtl="0" algn="l">
+              <a:lnSpc>
+                <a:spcPct val="150000"/>
+              </a:lnSpc>
+              <a:spcBef>
+                <a:spcPts val="0"/>
+              </a:spcBef>
+              <a:spcAft>
+                <a:spcPts val="0"/>
+              </a:spcAft>
+              <a:buNone/>
+            </a:pPr>
+            <a:r>
+              <a:rPr lang="en-US" sz="1650">
+                <a:solidFill>
+                  <a:srgbClr val="B5BAC1"/>
+                </a:solidFill>
+                <a:latin typeface="Inter"/>
+                <a:ea typeface="Inter"/>
+                <a:cs typeface="Inter"/>
+                <a:sym typeface="Inter"/>
+              </a:rPr>
+              <a:t>linkedin.com/in/arch-youssef</a:t>
+            </a:r>
+            <a:endParaRPr/>
+          </a:p>
+        </p:txBody>
+      </p:sp>
+      <p:sp>
+        <p:nvSpPr>
+          <p:cNvPr id="205" name="Google Shape;205;p23"/>
+          <p:cNvSpPr txBox="1"/>
+          <p:nvPr/>
+        </p:nvSpPr>
+        <p:spPr>
+          <a:xfrm>
+            <a:off x="4061936" y="5162828"/>
+            <a:ext cx="4375800" cy="254100"/>
+          </a:xfrm>
+          <a:prstGeom prst="rect">
+            <a:avLst/>
+          </a:prstGeom>
+          <a:noFill/>
+          <a:ln>
+            <a:noFill/>
+          </a:ln>
+        </p:spPr>
+        <p:txBody>
+          <a:bodyPr anchorCtr="0" anchor="t" bIns="0" lIns="0" spcFirstLastPara="1" rIns="0" wrap="square" tIns="0">
+            <a:spAutoFit/>
+          </a:bodyPr>
+          <a:lstStyle/>
+          <a:p>
+            <a:pPr indent="0" lvl="0" marL="0" marR="0" rtl="0" algn="l">
+              <a:lnSpc>
+                <a:spcPct val="150000"/>
+              </a:lnSpc>
+              <a:spcBef>
+                <a:spcPts val="0"/>
+              </a:spcBef>
+              <a:spcAft>
+                <a:spcPts val="0"/>
+              </a:spcAft>
+              <a:buNone/>
+            </a:pPr>
+            <a:r>
+              <a:rPr lang="en-US" sz="1650">
+                <a:solidFill>
+                  <a:srgbClr val="B5BAC1"/>
+                </a:solidFill>
+                <a:latin typeface="Inter"/>
+                <a:ea typeface="Inter"/>
+                <a:cs typeface="Inter"/>
+                <a:sym typeface="Inter"/>
+              </a:rPr>
+              <a:t>github.com/ArchYoussefAdel/BIM-and-YOU</a:t>
+            </a:r>
+            <a:endParaRPr sz="1650">
+              <a:solidFill>
+                <a:srgbClr val="B5BAC1"/>
+              </a:solidFill>
+              <a:latin typeface="Inter"/>
+              <a:ea typeface="Inter"/>
+              <a:cs typeface="Inter"/>
+              <a:sym typeface="Inter"/>
+            </a:endParaRPr>
+          </a:p>
+        </p:txBody>
+      </p:sp>
+    </p:spTree>
+  </p:cSld>
+  <p:clrMapOvr>
+    <a:masterClrMapping/>
+  </p:clrMapOvr>
+</p:sld>
+</file>
+
+<file path=ppt/slides/slide12.xml><?xml version="1.0" encoding="utf-8"?>
+<p:sld xmlns:a="http://schemas.openxmlformats.org/drawingml/2006/main" xmlns:r="http://schemas.openxmlformats.org/officeDocument/2006/relationships" xmlns:mc="http://schemas.openxmlformats.org/markup-compatibility/2006" xmlns:mv="urn:schemas-microsoft-com:mac:vml" xmlns:p="http://schemas.openxmlformats.org/presentationml/2006/main" xmlns:c="http://schemas.openxmlformats.org/drawingml/2006/chart" xmlns:dgm="http://schemas.openxmlformats.org/drawingml/2006/diagram" xmlns:o="urn:schemas-microsoft-com:office:office" xmlns:v="urn:schemas-microsoft-com:vml" xmlns:pvml="urn:schemas-microsoft-com:office:powerpoint" xmlns:com="http://schemas.openxmlformats.org/drawingml/2006/compatibility" xmlns:p14="http://schemas.microsoft.com/office/powerpoint/2010/main" xmlns:p15="http://schemas.microsoft.com/office/powerpoint/2012/main" xmlns:ahyp="http://schemas.microsoft.com/office/drawing/2018/hyperlinkcolor">
+  <p:cSld>
+    <p:bg>
+      <p:bgPr>
+        <a:solidFill>
+          <a:srgbClr val="1A1D21"/>
+        </a:solidFill>
+      </p:bgPr>
+    </p:bg>
+    <p:spTree>
+      <p:nvGrpSpPr>
+        <p:cNvPr id="209" name="Shape 209"/>
+        <p:cNvGrpSpPr/>
+        <p:nvPr/>
+      </p:nvGrpSpPr>
+      <p:grpSpPr>
+        <a:xfrm>
+          <a:off x="0" y="0"/>
+          <a:ext cx="0" cy="0"/>
+          <a:chOff x="0" y="0"/>
+          <a:chExt cx="0" cy="0"/>
+        </a:xfrm>
+      </p:grpSpPr>
+      <p:pic>
+        <p:nvPicPr>
+          <p:cNvPr descr="image.png" id="210" name="Google Shape;210;p24"/>
+          <p:cNvPicPr preferRelativeResize="0"/>
+          <p:nvPr/>
+        </p:nvPicPr>
+        <p:blipFill rotWithShape="1">
+          <a:blip r:embed="rId3">
+            <a:alphaModFix/>
+          </a:blip>
+          <a:srcRect b="0" l="0" r="0" t="0"/>
+          <a:stretch/>
+        </p:blipFill>
+        <p:spPr>
+          <a:xfrm>
+            <a:off x="0" y="0"/>
+            <a:ext cx="12192000" cy="6858000"/>
+          </a:xfrm>
+          <a:prstGeom prst="rect">
+            <a:avLst/>
+          </a:prstGeom>
+          <a:noFill/>
+          <a:ln>
+            <a:noFill/>
+          </a:ln>
+        </p:spPr>
+      </p:pic>
+      <p:sp>
+        <p:nvSpPr>
+          <p:cNvPr id="211" name="Google Shape;211;p24"/>
+          <p:cNvSpPr txBox="1"/>
+          <p:nvPr/>
+        </p:nvSpPr>
+        <p:spPr>
+          <a:xfrm>
+            <a:off x="2538349" y="1474981"/>
+            <a:ext cx="8210700" cy="150000"/>
+          </a:xfrm>
+          <a:prstGeom prst="rect">
+            <a:avLst/>
+          </a:prstGeom>
+          <a:noFill/>
+          <a:ln>
+            <a:noFill/>
+          </a:ln>
+        </p:spPr>
+        <p:txBody>
+          <a:bodyPr anchorCtr="0" anchor="t" bIns="0" lIns="0" spcFirstLastPara="1" rIns="0" wrap="square" tIns="0">
+            <a:spAutoFit/>
+          </a:bodyPr>
+          <a:lstStyle/>
+          <a:p>
+            <a:pPr indent="0" lvl="0" marL="0" marR="0" rtl="0" algn="l">
+              <a:lnSpc>
+                <a:spcPct val="149948"/>
+              </a:lnSpc>
+              <a:spcBef>
+                <a:spcPts val="0"/>
+              </a:spcBef>
+              <a:spcAft>
+                <a:spcPts val="0"/>
+              </a:spcAft>
+              <a:buNone/>
+            </a:pPr>
+            <a:r>
+              <a:rPr lang="en-US" sz="975">
+                <a:solidFill>
+                  <a:srgbClr val="B5BAC1"/>
+                </a:solidFill>
+                <a:latin typeface="Inter"/>
+                <a:ea typeface="Inter"/>
+                <a:cs typeface="Inter"/>
+                <a:sym typeface="Inter"/>
+              </a:rPr>
+              <a:t>https://biblus.accasoftware.com/es/wp-content/uploads/sites/3/2020/10/federacion-de-modelos-con-usBIM.jpg.webp</a:t>
+            </a:r>
+            <a:endParaRPr/>
+          </a:p>
+        </p:txBody>
+      </p:sp>
+      <p:sp>
+        <p:nvSpPr>
+          <p:cNvPr id="212" name="Google Shape;212;p24"/>
+          <p:cNvSpPr txBox="1"/>
+          <p:nvPr/>
+        </p:nvSpPr>
+        <p:spPr>
+          <a:xfrm>
+            <a:off x="581025" y="581025"/>
+            <a:ext cx="11581500" cy="519600"/>
+          </a:xfrm>
+          <a:prstGeom prst="rect">
+            <a:avLst/>
+          </a:prstGeom>
+          <a:noFill/>
+          <a:ln>
+            <a:noFill/>
+          </a:ln>
+        </p:spPr>
+        <p:txBody>
+          <a:bodyPr anchorCtr="0" anchor="t" bIns="0" lIns="0" spcFirstLastPara="1" rIns="0" wrap="square" tIns="0">
+            <a:spAutoFit/>
+          </a:bodyPr>
+          <a:lstStyle/>
+          <a:p>
+            <a:pPr indent="0" lvl="0" marL="0" marR="0" rtl="0" algn="l">
+              <a:spcBef>
+                <a:spcPts val="0"/>
+              </a:spcBef>
+              <a:spcAft>
+                <a:spcPts val="0"/>
+              </a:spcAft>
+              <a:buNone/>
+            </a:pPr>
+            <a:r>
+              <a:rPr b="0" i="0" lang="en-US" sz="3375" u="none" cap="none" strike="noStrike">
+                <a:solidFill>
+                  <a:srgbClr val="FFFFFF"/>
+                </a:solidFill>
+                <a:latin typeface="Inter ExtraBold"/>
+                <a:ea typeface="Inter ExtraBold"/>
+                <a:cs typeface="Inter ExtraBold"/>
+                <a:sym typeface="Inter ExtraBold"/>
+              </a:rPr>
+              <a:t>Sources</a:t>
+            </a:r>
+            <a:endParaRPr/>
+          </a:p>
+        </p:txBody>
+      </p:sp>
+      <p:pic>
+        <p:nvPicPr>
+          <p:cNvPr id="213" name="Google Shape;213;p24"/>
+          <p:cNvPicPr preferRelativeResize="0"/>
+          <p:nvPr/>
+        </p:nvPicPr>
+        <p:blipFill>
+          <a:blip r:embed="rId4">
+            <a:alphaModFix/>
+          </a:blip>
+          <a:stretch>
+            <a:fillRect/>
+          </a:stretch>
+        </p:blipFill>
+        <p:spPr>
+          <a:xfrm>
+            <a:off x="1270700" y="1474971"/>
+            <a:ext cx="1004225" cy="726100"/>
+          </a:xfrm>
+          <a:prstGeom prst="rect">
+            <a:avLst/>
+          </a:prstGeom>
+          <a:noFill/>
+          <a:ln>
+            <a:noFill/>
+          </a:ln>
+        </p:spPr>
+      </p:pic>
+      <p:sp>
+        <p:nvSpPr>
+          <p:cNvPr id="214" name="Google Shape;214;p24"/>
+          <p:cNvSpPr txBox="1"/>
+          <p:nvPr/>
+        </p:nvSpPr>
+        <p:spPr>
+          <a:xfrm>
+            <a:off x="2538349" y="1763031"/>
+            <a:ext cx="8210700" cy="150000"/>
+          </a:xfrm>
+          <a:prstGeom prst="rect">
+            <a:avLst/>
+          </a:prstGeom>
+          <a:noFill/>
+          <a:ln>
+            <a:noFill/>
+          </a:ln>
+        </p:spPr>
+        <p:txBody>
+          <a:bodyPr anchorCtr="0" anchor="t" bIns="0" lIns="0" spcFirstLastPara="1" rIns="0" wrap="square" tIns="0">
+            <a:spAutoFit/>
+          </a:bodyPr>
+          <a:lstStyle/>
+          <a:p>
+            <a:pPr indent="0" lvl="0" marL="0" marR="0" rtl="0" algn="l">
+              <a:lnSpc>
+                <a:spcPct val="149948"/>
+              </a:lnSpc>
+              <a:spcBef>
+                <a:spcPts val="0"/>
+              </a:spcBef>
+              <a:spcAft>
+                <a:spcPts val="0"/>
+              </a:spcAft>
+              <a:buNone/>
+            </a:pPr>
+            <a:r>
+              <a:rPr lang="en-US" sz="975">
+                <a:solidFill>
+                  <a:srgbClr val="B5BAC1"/>
+                </a:solidFill>
+                <a:latin typeface="Inter"/>
+                <a:ea typeface="Inter"/>
+                <a:cs typeface="Inter"/>
+                <a:sym typeface="Inter"/>
+              </a:rPr>
+              <a:t>biblus.</a:t>
+            </a:r>
+            <a:r>
+              <a:rPr lang="en-US" sz="975">
+                <a:solidFill>
+                  <a:srgbClr val="B5BAC1"/>
+                </a:solidFill>
+                <a:latin typeface="Inter"/>
+                <a:ea typeface="Inter"/>
+                <a:cs typeface="Inter"/>
+                <a:sym typeface="Inter"/>
+              </a:rPr>
+              <a:t>acca software</a:t>
+            </a:r>
+            <a:endParaRPr/>
+          </a:p>
+        </p:txBody>
+      </p:sp>
+    </p:spTree>
+  </p:cSld>
+  <p:clrMapOvr>
+    <a:masterClrMapping/>
+  </p:clrMapOvr>
+</p:sld>
+</file>
+
+<file path=ppt/slides/slide13.xml><?xml version="1.0" encoding="utf-8"?>
+<p:sld xmlns:a="http://schemas.openxmlformats.org/drawingml/2006/main" xmlns:r="http://schemas.openxmlformats.org/officeDocument/2006/relationships" xmlns:mc="http://schemas.openxmlformats.org/markup-compatibility/2006" xmlns:mv="urn:schemas-microsoft-com:mac:vml" xmlns:p="http://schemas.openxmlformats.org/presentationml/2006/main" xmlns:c="http://schemas.openxmlformats.org/drawingml/2006/chart" xmlns:dgm="http://schemas.openxmlformats.org/drawingml/2006/diagram" xmlns:o="urn:schemas-microsoft-com:office:office" xmlns:v="urn:schemas-microsoft-com:vml" xmlns:pvml="urn:schemas-microsoft-com:office:powerpoint" xmlns:com="http://schemas.openxmlformats.org/drawingml/2006/compatibility" xmlns:p14="http://schemas.microsoft.com/office/powerpoint/2010/main" xmlns:p15="http://schemas.microsoft.com/office/powerpoint/2012/main" xmlns:ahyp="http://schemas.microsoft.com/office/drawing/2018/hyperlinkcolor">
+  <p:cSld>
+    <p:bg>
+      <p:bgPr>
+        <a:solidFill>
+          <a:srgbClr val="1A1D21"/>
+        </a:solidFill>
+      </p:bgPr>
+    </p:bg>
+    <p:spTree>
+      <p:nvGrpSpPr>
+        <p:cNvPr id="218" name="Shape 218"/>
+        <p:cNvGrpSpPr/>
+        <p:nvPr/>
+      </p:nvGrpSpPr>
+      <p:grpSpPr>
+        <a:xfrm>
+          <a:off x="0" y="0"/>
+          <a:ext cx="0" cy="0"/>
+          <a:chOff x="0" y="0"/>
+          <a:chExt cx="0" cy="0"/>
+        </a:xfrm>
+      </p:grpSpPr>
+      <p:pic>
+        <p:nvPicPr>
+          <p:cNvPr id="219" name="Google Shape;219;p25" title="INTRO.png"/>
+          <p:cNvPicPr preferRelativeResize="0"/>
+          <p:nvPr/>
+        </p:nvPicPr>
+        <p:blipFill rotWithShape="1">
+          <a:blip r:embed="rId3">
+            <a:alphaModFix/>
+          </a:blip>
+          <a:srcRect b="20" l="0" r="0" t="20"/>
+          <a:stretch/>
+        </p:blipFill>
+        <p:spPr>
+          <a:xfrm>
+            <a:off x="0" y="0"/>
+            <a:ext cx="12191997" cy="6858000"/>
+          </a:xfrm>
+          <a:prstGeom prst="rect">
+            <a:avLst/>
+          </a:prstGeom>
+          <a:noFill/>
+          <a:ln>
+            <a:noFill/>
+          </a:ln>
+        </p:spPr>
+      </p:pic>
+      <p:sp>
+        <p:nvSpPr>
+          <p:cNvPr id="220" name="Google Shape;220;p25"/>
+          <p:cNvSpPr/>
+          <p:nvPr/>
+        </p:nvSpPr>
+        <p:spPr>
+          <a:xfrm>
+            <a:off x="1295400" y="3886200"/>
+            <a:ext cx="9711900" cy="1783200"/>
+          </a:xfrm>
+          <a:prstGeom prst="roundRect">
+            <a:avLst>
+              <a:gd fmla="val 7494" name="adj"/>
+            </a:avLst>
+          </a:prstGeom>
+          <a:solidFill>
+            <a:srgbClr val="666666"/>
+          </a:solidFill>
+          <a:ln>
+            <a:noFill/>
+          </a:ln>
+          <a:effectLst>
+            <a:outerShdw blurRad="285750" rotWithShape="0" algn="bl" dir="8100000" dist="142875">
+              <a:srgbClr val="000000">
+                <a:alpha val="35000"/>
+              </a:srgbClr>
+            </a:outerShdw>
+          </a:effectLst>
+        </p:spPr>
+        <p:txBody>
+          <a:bodyPr anchorCtr="0" anchor="ctr" bIns="164575" lIns="228600" spcFirstLastPara="1" rIns="182875" wrap="square" tIns="109725">
+            <a:noAutofit/>
+          </a:bodyPr>
+          <a:lstStyle/>
+          <a:p>
+            <a:pPr indent="0" lvl="0" marL="0" rtl="0" algn="l">
+              <a:spcBef>
+                <a:spcPts val="0"/>
+              </a:spcBef>
+              <a:spcAft>
+                <a:spcPts val="0"/>
+              </a:spcAft>
+              <a:buNone/>
+            </a:pPr>
+            <a:r>
+              <a:rPr lang="en-US" sz="6000">
+                <a:solidFill>
+                  <a:schemeClr val="lt1"/>
+                </a:solidFill>
+                <a:latin typeface="Inter ExtraBold"/>
+                <a:ea typeface="Inter ExtraBold"/>
+                <a:cs typeface="Inter ExtraBold"/>
+                <a:sym typeface="Inter ExtraBold"/>
+              </a:rPr>
+              <a:t>BIM </a:t>
+            </a:r>
+            <a:r>
+              <a:rPr lang="en-US" sz="6000">
+                <a:solidFill>
+                  <a:srgbClr val="0696D7"/>
+                </a:solidFill>
+                <a:latin typeface="Inter ExtraBold"/>
+                <a:ea typeface="Inter ExtraBold"/>
+                <a:cs typeface="Inter ExtraBold"/>
+                <a:sym typeface="Inter ExtraBold"/>
+              </a:rPr>
+              <a:t>&amp;&amp;</a:t>
+            </a:r>
+            <a:r>
+              <a:rPr lang="en-US" sz="6000">
+                <a:solidFill>
+                  <a:schemeClr val="lt1"/>
+                </a:solidFill>
+                <a:latin typeface="Inter ExtraBold"/>
+                <a:ea typeface="Inter ExtraBold"/>
+                <a:cs typeface="Inter ExtraBold"/>
+                <a:sym typeface="Inter ExtraBold"/>
+              </a:rPr>
+              <a:t> YOU</a:t>
+            </a:r>
+            <a:endParaRPr sz="6000">
+              <a:solidFill>
+                <a:schemeClr val="lt1"/>
+              </a:solidFill>
+              <a:latin typeface="Inter ExtraBold"/>
+              <a:ea typeface="Inter ExtraBold"/>
+              <a:cs typeface="Inter ExtraBold"/>
+              <a:sym typeface="Inter ExtraBold"/>
+            </a:endParaRPr>
+          </a:p>
+          <a:p>
+            <a:pPr indent="0" lvl="0" marL="0" rtl="0" algn="l">
+              <a:lnSpc>
+                <a:spcPct val="150000"/>
+              </a:lnSpc>
+              <a:spcBef>
+                <a:spcPts val="0"/>
+              </a:spcBef>
+              <a:spcAft>
+                <a:spcPts val="0"/>
+              </a:spcAft>
+              <a:buNone/>
+            </a:pPr>
+            <a:r>
+              <a:rPr lang="en-US" sz="2250">
+                <a:solidFill>
+                  <a:schemeClr val="lt1"/>
+                </a:solidFill>
+                <a:latin typeface="Inter"/>
+                <a:ea typeface="Inter"/>
+                <a:cs typeface="Inter"/>
+                <a:sym typeface="Inter"/>
+              </a:rPr>
+              <a:t>EP.02: </a:t>
+            </a:r>
+            <a:r>
+              <a:rPr lang="en-US" sz="2250">
+                <a:solidFill>
+                  <a:srgbClr val="0696D7"/>
+                </a:solidFill>
+                <a:latin typeface="Inter"/>
+                <a:ea typeface="Inter"/>
+                <a:cs typeface="Inter"/>
+                <a:sym typeface="Inter"/>
+              </a:rPr>
+              <a:t>1-Click Model</a:t>
+            </a:r>
+            <a:r>
+              <a:rPr lang="en-US" sz="2250">
+                <a:solidFill>
+                  <a:schemeClr val="lt1"/>
+                </a:solidFill>
+                <a:latin typeface="Inter"/>
+                <a:ea typeface="Inter"/>
+                <a:cs typeface="Inter"/>
+                <a:sym typeface="Inter"/>
+              </a:rPr>
+              <a:t> Prep: Batch-Hiding Revit Links for Navisworks </a:t>
+            </a:r>
+            <a:endParaRPr sz="6000">
+              <a:solidFill>
+                <a:schemeClr val="lt1"/>
+              </a:solidFill>
+              <a:latin typeface="Inter ExtraBold"/>
+              <a:ea typeface="Inter ExtraBold"/>
+              <a:cs typeface="Inter ExtraBold"/>
+              <a:sym typeface="Inter ExtraBold"/>
+            </a:endParaRPr>
+          </a:p>
+          <a:p>
+            <a:pPr indent="0" lvl="0" marL="0" rtl="0" algn="ctr">
+              <a:spcBef>
+                <a:spcPts val="0"/>
+              </a:spcBef>
+              <a:spcAft>
+                <a:spcPts val="0"/>
+              </a:spcAft>
+              <a:buNone/>
+            </a:pPr>
+            <a:r>
+              <a:t/>
+            </a:r>
+            <a:endParaRPr>
+              <a:latin typeface="Calibri"/>
+              <a:ea typeface="Calibri"/>
+              <a:cs typeface="Calibri"/>
+              <a:sym typeface="Calibri"/>
+            </a:endParaRPr>
+          </a:p>
+        </p:txBody>
+      </p:sp>
+      <p:sp>
+        <p:nvSpPr>
+          <p:cNvPr id="221" name="Google Shape;221;p25"/>
+          <p:cNvSpPr txBox="1"/>
+          <p:nvPr/>
+        </p:nvSpPr>
+        <p:spPr>
+          <a:xfrm>
+            <a:off x="2265650" y="876650"/>
+            <a:ext cx="1481100" cy="3263100"/>
+          </a:xfrm>
+          <a:prstGeom prst="rect">
+            <a:avLst/>
+          </a:prstGeom>
+          <a:noFill/>
+          <a:ln>
+            <a:noFill/>
+          </a:ln>
+        </p:spPr>
+        <p:txBody>
+          <a:bodyPr anchorCtr="0" anchor="t" bIns="91425" lIns="91425" spcFirstLastPara="1" rIns="91425" wrap="square" tIns="91425">
+            <a:spAutoFit/>
+          </a:bodyPr>
+          <a:lstStyle/>
+          <a:p>
+            <a:pPr indent="0" lvl="0" marL="0" rtl="0" algn="l">
+              <a:spcBef>
+                <a:spcPts val="0"/>
+              </a:spcBef>
+              <a:spcAft>
+                <a:spcPts val="0"/>
+              </a:spcAft>
+              <a:buNone/>
+            </a:pPr>
+            <a:r>
+              <a:rPr lang="en-US" sz="20000">
+                <a:solidFill>
+                  <a:srgbClr val="FF0000"/>
+                </a:solidFill>
+                <a:latin typeface="Calibri"/>
+                <a:ea typeface="Calibri"/>
+                <a:cs typeface="Calibri"/>
+                <a:sym typeface="Calibri"/>
+              </a:rPr>
+              <a:t>X</a:t>
+            </a:r>
+            <a:endParaRPr sz="20000">
+              <a:solidFill>
+                <a:srgbClr val="FF0000"/>
+              </a:solidFill>
+              <a:latin typeface="Calibri"/>
+              <a:ea typeface="Calibri"/>
+              <a:cs typeface="Calibri"/>
+              <a:sym typeface="Calibri"/>
+            </a:endParaRPr>
+          </a:p>
+        </p:txBody>
+      </p:sp>
+    </p:spTree>
+  </p:cSld>
+  <p:clrMapOvr>
+    <a:masterClrMapping/>
+  </p:clrMapOvr>
+</p:sld>
+</file>
+
+<file path=ppt/slides/slide14.xml><?xml version="1.0" encoding="utf-8"?>
+<p:sld xmlns:a="http://schemas.openxmlformats.org/drawingml/2006/main" xmlns:r="http://schemas.openxmlformats.org/officeDocument/2006/relationships" xmlns:mc="http://schemas.openxmlformats.org/markup-compatibility/2006" xmlns:mv="urn:schemas-microsoft-com:mac:vml" xmlns:p="http://schemas.openxmlformats.org/presentationml/2006/main" xmlns:c="http://schemas.openxmlformats.org/drawingml/2006/chart" xmlns:dgm="http://schemas.openxmlformats.org/drawingml/2006/diagram" xmlns:o="urn:schemas-microsoft-com:office:office" xmlns:v="urn:schemas-microsoft-com:vml" xmlns:pvml="urn:schemas-microsoft-com:office:powerpoint" xmlns:com="http://schemas.openxmlformats.org/drawingml/2006/compatibility" xmlns:p14="http://schemas.microsoft.com/office/powerpoint/2010/main" xmlns:p15="http://schemas.microsoft.com/office/powerpoint/2012/main" xmlns:ahyp="http://schemas.microsoft.com/office/drawing/2018/hyperlinkcolor">
+  <p:cSld>
+    <p:bg>
+      <p:bgPr>
+        <a:solidFill>
+          <a:srgbClr val="1A1D21"/>
+        </a:solidFill>
+      </p:bgPr>
+    </p:bg>
+    <p:spTree>
+      <p:nvGrpSpPr>
+        <p:cNvPr id="225" name="Shape 225"/>
+        <p:cNvGrpSpPr/>
+        <p:nvPr/>
+      </p:nvGrpSpPr>
+      <p:grpSpPr>
+        <a:xfrm>
+          <a:off x="0" y="0"/>
+          <a:ext cx="0" cy="0"/>
+          <a:chOff x="0" y="0"/>
+          <a:chExt cx="0" cy="0"/>
+        </a:xfrm>
+      </p:grpSpPr>
+      <p:sp>
+        <p:nvSpPr>
+          <p:cNvPr id="226" name="Google Shape;226;p26"/>
+          <p:cNvSpPr txBox="1"/>
+          <p:nvPr/>
+        </p:nvSpPr>
+        <p:spPr>
+          <a:xfrm>
+            <a:off x="666900" y="1396500"/>
+            <a:ext cx="10858200" cy="4065000"/>
+          </a:xfrm>
+          <a:prstGeom prst="rect">
+            <a:avLst/>
+          </a:prstGeom>
+          <a:noFill/>
+          <a:ln>
+            <a:noFill/>
+          </a:ln>
+        </p:spPr>
+        <p:txBody>
+          <a:bodyPr anchorCtr="0" anchor="t" bIns="0" lIns="0" spcFirstLastPara="1" rIns="0" wrap="square" tIns="0">
+            <a:spAutoFit/>
+          </a:bodyPr>
+          <a:lstStyle/>
+          <a:p>
+            <a:pPr indent="0" lvl="0" marL="0" marR="0" rtl="0" algn="ctr">
+              <a:lnSpc>
+                <a:spcPct val="115000"/>
+              </a:lnSpc>
+              <a:spcBef>
+                <a:spcPts val="0"/>
+              </a:spcBef>
+              <a:spcAft>
+                <a:spcPts val="0"/>
+              </a:spcAft>
+              <a:buNone/>
+            </a:pPr>
+            <a:r>
+              <a:rPr b="0" i="0" lang="en-US" sz="6000" u="none" cap="none" strike="noStrike">
+                <a:solidFill>
+                  <a:srgbClr val="FFFFFF"/>
+                </a:solidFill>
+                <a:latin typeface="Inter ExtraBold"/>
+                <a:ea typeface="Inter ExtraBold"/>
+                <a:cs typeface="Inter ExtraBold"/>
+                <a:sym typeface="Inter ExtraBold"/>
+              </a:rPr>
+              <a:t>BIM </a:t>
+            </a:r>
+            <a:r>
+              <a:rPr b="0" i="0" lang="en-US" sz="6000" u="none" cap="none" strike="noStrike">
+                <a:solidFill>
+                  <a:srgbClr val="0696D7"/>
+                </a:solidFill>
+                <a:latin typeface="Inter ExtraBold"/>
+                <a:ea typeface="Inter ExtraBold"/>
+                <a:cs typeface="Inter ExtraBold"/>
+                <a:sym typeface="Inter ExtraBold"/>
+              </a:rPr>
+              <a:t>&amp;&amp;</a:t>
+            </a:r>
+            <a:r>
+              <a:rPr b="0" i="0" lang="en-US" sz="6000" u="none" cap="none" strike="noStrike">
+                <a:solidFill>
+                  <a:srgbClr val="FFFFFF"/>
+                </a:solidFill>
+                <a:latin typeface="Inter ExtraBold"/>
+                <a:ea typeface="Inter ExtraBold"/>
+                <a:cs typeface="Inter ExtraBold"/>
+                <a:sym typeface="Inter ExtraBold"/>
+              </a:rPr>
+              <a:t> YOU</a:t>
+            </a:r>
+            <a:endParaRPr b="0" i="0" sz="6000" u="none" cap="none" strike="noStrike">
+              <a:solidFill>
+                <a:srgbClr val="FFFFFF"/>
+              </a:solidFill>
+              <a:latin typeface="Inter ExtraBold"/>
+              <a:ea typeface="Inter ExtraBold"/>
+              <a:cs typeface="Inter ExtraBold"/>
+              <a:sym typeface="Inter ExtraBold"/>
+            </a:endParaRPr>
+          </a:p>
+          <a:p>
+            <a:pPr indent="0" lvl="0" marL="0" rtl="0" algn="ctr">
+              <a:lnSpc>
+                <a:spcPct val="115000"/>
+              </a:lnSpc>
+              <a:spcBef>
+                <a:spcPts val="0"/>
+              </a:spcBef>
+              <a:spcAft>
+                <a:spcPts val="0"/>
+              </a:spcAft>
+              <a:buSzPts val="1100"/>
+              <a:buNone/>
+            </a:pPr>
+            <a:r>
+              <a:rPr b="1" lang="en-US" sz="2200">
+                <a:solidFill>
+                  <a:schemeClr val="lt1"/>
+                </a:solidFill>
+                <a:latin typeface="Inter"/>
+                <a:ea typeface="Inter"/>
+                <a:cs typeface="Inter"/>
+                <a:sym typeface="Inter"/>
+              </a:rPr>
+              <a:t>EP.02: </a:t>
+            </a:r>
+            <a:r>
+              <a:rPr b="1" lang="en-US" sz="2200">
+                <a:solidFill>
+                  <a:srgbClr val="0696D7"/>
+                </a:solidFill>
+                <a:latin typeface="Inter"/>
+                <a:ea typeface="Inter"/>
+                <a:cs typeface="Inter"/>
+                <a:sym typeface="Inter"/>
+              </a:rPr>
+              <a:t>1-Click Model</a:t>
+            </a:r>
+            <a:r>
+              <a:rPr b="1" lang="en-US" sz="2200">
+                <a:solidFill>
+                  <a:schemeClr val="lt1"/>
+                </a:solidFill>
+                <a:latin typeface="Inter"/>
+                <a:ea typeface="Inter"/>
+                <a:cs typeface="Inter"/>
+                <a:sym typeface="Inter"/>
+              </a:rPr>
+              <a:t> Prep: Batch-Hiding Revit Links for Navisworks</a:t>
+            </a:r>
+            <a:endParaRPr b="1" sz="2200">
+              <a:solidFill>
+                <a:schemeClr val="lt1"/>
+              </a:solidFill>
+              <a:latin typeface="Inter"/>
+              <a:ea typeface="Inter"/>
+              <a:cs typeface="Inter"/>
+              <a:sym typeface="Inter"/>
+            </a:endParaRPr>
+          </a:p>
+          <a:p>
+            <a:pPr indent="0" lvl="0" marL="0" rtl="0" algn="ctr">
+              <a:lnSpc>
+                <a:spcPct val="115000"/>
+              </a:lnSpc>
+              <a:spcBef>
+                <a:spcPts val="0"/>
+              </a:spcBef>
+              <a:spcAft>
+                <a:spcPts val="0"/>
+              </a:spcAft>
+              <a:buSzPts val="1100"/>
+              <a:buNone/>
+            </a:pPr>
+            <a:r>
+              <a:t/>
+            </a:r>
+            <a:endParaRPr b="1" sz="2200">
+              <a:solidFill>
+                <a:schemeClr val="lt1"/>
+              </a:solidFill>
+              <a:latin typeface="Inter"/>
+              <a:ea typeface="Inter"/>
+              <a:cs typeface="Inter"/>
+              <a:sym typeface="Inter"/>
+            </a:endParaRPr>
+          </a:p>
+          <a:p>
+            <a:pPr indent="0" lvl="0" marL="0" rtl="0" algn="ctr">
+              <a:lnSpc>
+                <a:spcPct val="115000"/>
+              </a:lnSpc>
+              <a:spcBef>
+                <a:spcPts val="0"/>
+              </a:spcBef>
+              <a:spcAft>
+                <a:spcPts val="0"/>
+              </a:spcAft>
+              <a:buClr>
+                <a:schemeClr val="dk1"/>
+              </a:buClr>
+              <a:buSzPts val="1100"/>
+              <a:buFont typeface="Arial"/>
+              <a:buNone/>
+            </a:pPr>
+            <a:r>
+              <a:rPr lang="en-US" sz="2200">
+                <a:solidFill>
+                  <a:srgbClr val="FFFFFF"/>
+                </a:solidFill>
+                <a:latin typeface="Inter ExtraBold"/>
+                <a:ea typeface="Inter ExtraBold"/>
+                <a:cs typeface="Inter ExtraBold"/>
+                <a:sym typeface="Inter ExtraBold"/>
+              </a:rPr>
+              <a:t>                   Thanks for watching!</a:t>
+            </a:r>
+            <a:endParaRPr sz="2200">
+              <a:solidFill>
+                <a:srgbClr val="FFFFFF"/>
+              </a:solidFill>
+              <a:latin typeface="Inter ExtraBold"/>
+              <a:ea typeface="Inter ExtraBold"/>
+              <a:cs typeface="Inter ExtraBold"/>
+              <a:sym typeface="Inter ExtraBold"/>
+            </a:endParaRPr>
+          </a:p>
+          <a:p>
+            <a:pPr indent="0" lvl="0" marL="0" rtl="0" algn="ctr">
+              <a:lnSpc>
+                <a:spcPct val="115000"/>
+              </a:lnSpc>
+              <a:spcBef>
+                <a:spcPts val="0"/>
+              </a:spcBef>
+              <a:spcAft>
+                <a:spcPts val="0"/>
+              </a:spcAft>
+              <a:buClr>
+                <a:schemeClr val="dk1"/>
+              </a:buClr>
+              <a:buSzPts val="1100"/>
+              <a:buFont typeface="Arial"/>
+              <a:buNone/>
+            </a:pPr>
+            <a:r>
+              <a:rPr lang="en-US" sz="2200">
+                <a:solidFill>
+                  <a:srgbClr val="FFFFFF"/>
+                </a:solidFill>
+                <a:latin typeface="Inter ExtraBold"/>
+                <a:ea typeface="Inter ExtraBold"/>
+                <a:cs typeface="Inter ExtraBold"/>
+                <a:sym typeface="Inter ExtraBold"/>
+              </a:rPr>
+              <a:t>  👍 Like &amp; Comment: What workflow should I automate next?</a:t>
+            </a:r>
+            <a:endParaRPr sz="2200">
+              <a:solidFill>
+                <a:srgbClr val="FFFFFF"/>
+              </a:solidFill>
+              <a:latin typeface="Inter ExtraBold"/>
+              <a:ea typeface="Inter ExtraBold"/>
+              <a:cs typeface="Inter ExtraBold"/>
+              <a:sym typeface="Inter ExtraBold"/>
+            </a:endParaRPr>
+          </a:p>
+          <a:p>
+            <a:pPr indent="0" lvl="0" marL="0" rtl="0" algn="ctr">
+              <a:lnSpc>
+                <a:spcPct val="115000"/>
+              </a:lnSpc>
+              <a:spcBef>
+                <a:spcPts val="0"/>
+              </a:spcBef>
+              <a:spcAft>
+                <a:spcPts val="0"/>
+              </a:spcAft>
+              <a:buClr>
+                <a:schemeClr val="dk1"/>
+              </a:buClr>
+              <a:buSzPts val="1100"/>
+              <a:buFont typeface="Arial"/>
+              <a:buNone/>
+            </a:pPr>
+            <a:r>
+              <a:rPr lang="en-US" sz="2200">
+                <a:solidFill>
+                  <a:srgbClr val="FFFFFF"/>
+                </a:solidFill>
+                <a:latin typeface="Inter ExtraBold"/>
+                <a:ea typeface="Inter ExtraBold"/>
+                <a:cs typeface="Inter ExtraBold"/>
+                <a:sym typeface="Inter ExtraBold"/>
+              </a:rPr>
+              <a:t>    📥</a:t>
+            </a:r>
+            <a:r>
+              <a:rPr lang="en-US" sz="2200">
+                <a:solidFill>
+                  <a:srgbClr val="0696D7"/>
+                </a:solidFill>
+                <a:latin typeface="Inter ExtraBold"/>
+                <a:ea typeface="Inter ExtraBold"/>
+                <a:cs typeface="Inter ExtraBold"/>
+                <a:sym typeface="Inter ExtraBold"/>
+              </a:rPr>
+              <a:t>Free</a:t>
+            </a:r>
+            <a:r>
+              <a:rPr lang="en-US" sz="2200">
+                <a:solidFill>
+                  <a:srgbClr val="FFFFFF"/>
+                </a:solidFill>
+                <a:latin typeface="Inter ExtraBold"/>
+                <a:ea typeface="Inter ExtraBold"/>
+                <a:cs typeface="Inter ExtraBold"/>
+                <a:sym typeface="Inter ExtraBold"/>
+              </a:rPr>
+              <a:t> Dynamo Script &amp; Presentation pinned in comments.</a:t>
+            </a:r>
+            <a:endParaRPr sz="2200">
+              <a:solidFill>
+                <a:srgbClr val="FFFFFF"/>
+              </a:solidFill>
+              <a:latin typeface="Inter ExtraBold"/>
+              <a:ea typeface="Inter ExtraBold"/>
+              <a:cs typeface="Inter ExtraBold"/>
+              <a:sym typeface="Inter ExtraBold"/>
+            </a:endParaRPr>
+          </a:p>
+          <a:p>
+            <a:pPr indent="0" lvl="0" marL="0" rtl="0" algn="ctr">
+              <a:lnSpc>
+                <a:spcPct val="115000"/>
+              </a:lnSpc>
+              <a:spcBef>
+                <a:spcPts val="0"/>
+              </a:spcBef>
+              <a:spcAft>
+                <a:spcPts val="0"/>
+              </a:spcAft>
+              <a:buClr>
+                <a:schemeClr val="dk1"/>
+              </a:buClr>
+              <a:buSzPts val="1100"/>
+              <a:buFont typeface="Arial"/>
+              <a:buNone/>
+            </a:pPr>
+            <a:r>
+              <a:t/>
+            </a:r>
+            <a:endParaRPr sz="2200">
+              <a:solidFill>
+                <a:srgbClr val="FFFFFF"/>
+              </a:solidFill>
+              <a:latin typeface="Inter ExtraBold"/>
+              <a:ea typeface="Inter ExtraBold"/>
+              <a:cs typeface="Inter ExtraBold"/>
+              <a:sym typeface="Inter ExtraBold"/>
+            </a:endParaRPr>
+          </a:p>
+          <a:p>
+            <a:pPr indent="0" lvl="0" marL="0" rtl="0" algn="ctr">
+              <a:lnSpc>
+                <a:spcPct val="115000"/>
+              </a:lnSpc>
+              <a:spcBef>
+                <a:spcPts val="0"/>
+              </a:spcBef>
+              <a:spcAft>
+                <a:spcPts val="0"/>
+              </a:spcAft>
+              <a:buClr>
+                <a:schemeClr val="dk1"/>
+              </a:buClr>
+              <a:buSzPts val="1100"/>
+              <a:buFont typeface="Arial"/>
+              <a:buNone/>
+            </a:pPr>
+            <a:r>
+              <a:rPr lang="en-US" sz="2200">
+                <a:solidFill>
+                  <a:srgbClr val="FFFFFF"/>
+                </a:solidFill>
+                <a:latin typeface="Inter ExtraBold"/>
+                <a:ea typeface="Inter ExtraBold"/>
+                <a:cs typeface="Inter ExtraBold"/>
+                <a:sym typeface="Inter ExtraBold"/>
+              </a:rPr>
+              <a:t>        Youssef Adel | Senior BIM Coordinator</a:t>
+            </a:r>
+            <a:endParaRPr sz="2200">
+              <a:solidFill>
+                <a:srgbClr val="FFFFFF"/>
+              </a:solidFill>
+              <a:latin typeface="Inter ExtraBold"/>
+              <a:ea typeface="Inter ExtraBold"/>
+              <a:cs typeface="Inter ExtraBold"/>
+              <a:sym typeface="Inter ExtraBold"/>
+            </a:endParaRPr>
+          </a:p>
+          <a:p>
+            <a:pPr indent="0" lvl="0" marL="0" marR="0" rtl="0" algn="ctr">
+              <a:lnSpc>
+                <a:spcPct val="115000"/>
+              </a:lnSpc>
+              <a:spcBef>
+                <a:spcPts val="0"/>
+              </a:spcBef>
+              <a:spcAft>
+                <a:spcPts val="0"/>
+              </a:spcAft>
+              <a:buNone/>
+            </a:pPr>
+            <a:r>
+              <a:t/>
+            </a:r>
+            <a:endParaRPr sz="1800">
+              <a:solidFill>
+                <a:srgbClr val="FFFFFF"/>
+              </a:solidFill>
+              <a:latin typeface="Inter ExtraBold"/>
+              <a:ea typeface="Inter ExtraBold"/>
+              <a:cs typeface="Inter ExtraBold"/>
+              <a:sym typeface="Inter ExtraBold"/>
+            </a:endParaRPr>
           </a:p>
         </p:txBody>
       </p:sp>
@@ -12967,7 +15522,7 @@
         </p:blipFill>
         <p:spPr>
           <a:xfrm>
-            <a:off x="3988691" y="4255196"/>
+            <a:off x="3739016" y="5177046"/>
             <a:ext cx="219075" cy="228600"/>
           </a:xfrm>
           <a:prstGeom prst="rect">
@@ -12995,7 +15550,7 @@
         </p:blipFill>
         <p:spPr>
           <a:xfrm>
-            <a:off x="3969428" y="5065496"/>
+            <a:off x="3739028" y="4700771"/>
             <a:ext cx="219075" cy="218535"/>
           </a:xfrm>
           <a:prstGeom prst="rect">
@@ -13015,8 +15570,8 @@
         </p:nvSpPr>
         <p:spPr>
           <a:xfrm>
-            <a:off x="4311607" y="5083266"/>
-            <a:ext cx="5473800" cy="254100"/>
+            <a:off x="4077345" y="4718550"/>
+            <a:ext cx="4375800" cy="254100"/>
           </a:xfrm>
           <a:prstGeom prst="rect">
             <a:avLst/>
@@ -13057,6 +15612,67 @@
               <a:t>linkedin.com/in/arch-youssef</a:t>
             </a:r>
             <a:endParaRPr/>
+          </a:p>
+        </p:txBody>
+      </p:sp>
+      <p:sp>
+        <p:nvSpPr>
+          <p:cNvPr id="138" name="Google Shape;138;p17"/>
+          <p:cNvSpPr txBox="1"/>
+          <p:nvPr/>
+        </p:nvSpPr>
+        <p:spPr>
+          <a:xfrm>
+            <a:off x="4061936" y="5162828"/>
+            <a:ext cx="4375800" cy="254100"/>
+          </a:xfrm>
+          <a:prstGeom prst="rect">
+            <a:avLst/>
+          </a:prstGeom>
+          <a:noFill/>
+          <a:ln>
+            <a:noFill/>
+          </a:ln>
+        </p:spPr>
+        <p:txBody>
+          <a:bodyPr anchorCtr="0" anchor="t" bIns="0" lIns="0" spcFirstLastPara="1" rIns="0" wrap="square" tIns="0">
+            <a:spAutoFit/>
+          </a:bodyPr>
+          <a:lstStyle/>
+          <a:p>
+            <a:pPr indent="0" lvl="0" marL="0" marR="0" rtl="0" algn="l">
+              <a:lnSpc>
+                <a:spcPct val="150000"/>
+              </a:lnSpc>
+              <a:spcBef>
+                <a:spcPts val="0"/>
+              </a:spcBef>
+              <a:spcAft>
+                <a:spcPts val="0"/>
+              </a:spcAft>
+              <a:buNone/>
+            </a:pPr>
+            <a:r>
+              <a:rPr lang="en-US" sz="1650">
+                <a:solidFill>
+                  <a:srgbClr val="B5BAC1"/>
+                </a:solidFill>
+                <a:latin typeface="Inter"/>
+                <a:ea typeface="Inter"/>
+                <a:cs typeface="Inter"/>
+                <a:sym typeface="Inter"/>
+              </a:rPr>
+              <a:t>github.com/ArchYoussefAdel/BIM-and-YOU</a:t>
+            </a:r>
+            <a:endParaRPr sz="1650">
+              <a:solidFill>
+                <a:srgbClr val="B5BAC1"/>
+              </a:solidFill>
+              <a:latin typeface="Inter"/>
+              <a:ea typeface="Inter"/>
+              <a:cs typeface="Inter"/>
+              <a:sym typeface="Inter"/>
+            </a:endParaRPr>
           </a:p>
         </p:txBody>
       </p:sp>
@@ -13080,7 +15696,7 @@
     </p:bg>
     <p:spTree>
       <p:nvGrpSpPr>
-        <p:cNvPr id="141" name="Shape 141"/>
+        <p:cNvPr id="142" name="Shape 142"/>
         <p:cNvGrpSpPr/>
         <p:nvPr/>
       </p:nvGrpSpPr>
@@ -13094,7 +15710,7 @@
       </p:grpSpPr>
       <p:pic>
         <p:nvPicPr>
-          <p:cNvPr descr="image.png" id="142" name="Google Shape;142;p18"/>
+          <p:cNvPr descr="image.png" id="143" name="Google Shape;143;p18"/>
           <p:cNvPicPr preferRelativeResize="0"/>
           <p:nvPr/>
         </p:nvPicPr>
@@ -13121,7 +15737,7 @@
       </p:pic>
       <p:sp>
         <p:nvSpPr>
-          <p:cNvPr id="143" name="Google Shape;143;p18"/>
+          <p:cNvPr id="144" name="Google Shape;144;p18"/>
           <p:cNvSpPr txBox="1"/>
           <p:nvPr/>
         </p:nvSpPr>
@@ -13174,7 +15790,7 @@
       </p:sp>
       <p:sp>
         <p:nvSpPr>
-          <p:cNvPr id="144" name="Google Shape;144;p18"/>
+          <p:cNvPr id="145" name="Google Shape;145;p18"/>
           <p:cNvSpPr txBox="1"/>
           <p:nvPr/>
         </p:nvSpPr>
@@ -13224,7 +15840,7 @@
       </p:sp>
       <p:pic>
         <p:nvPicPr>
-          <p:cNvPr id="145" name="Google Shape;145;p18"/>
+          <p:cNvPr id="146" name="Google Shape;146;p18"/>
           <p:cNvPicPr preferRelativeResize="0"/>
           <p:nvPr/>
         </p:nvPicPr>
@@ -13258,7 +15874,1780 @@
 </p:sld>
 </file>
 
+<file path=ppt/slides/slide7.xml><?xml version="1.0" encoding="utf-8"?>
+<p:sld xmlns:a="http://schemas.openxmlformats.org/drawingml/2006/main" xmlns:r="http://schemas.openxmlformats.org/officeDocument/2006/relationships" xmlns:mc="http://schemas.openxmlformats.org/markup-compatibility/2006" xmlns:mv="urn:schemas-microsoft-com:mac:vml" xmlns:p="http://schemas.openxmlformats.org/presentationml/2006/main" xmlns:c="http://schemas.openxmlformats.org/drawingml/2006/chart" xmlns:dgm="http://schemas.openxmlformats.org/drawingml/2006/diagram" xmlns:o="urn:schemas-microsoft-com:office:office" xmlns:v="urn:schemas-microsoft-com:vml" xmlns:pvml="urn:schemas-microsoft-com:office:powerpoint" xmlns:com="http://schemas.openxmlformats.org/drawingml/2006/compatibility" xmlns:p14="http://schemas.microsoft.com/office/powerpoint/2010/main" xmlns:p15="http://schemas.microsoft.com/office/powerpoint/2012/main" xmlns:ahyp="http://schemas.microsoft.com/office/drawing/2018/hyperlinkcolor">
+  <p:cSld>
+    <p:bg>
+      <p:bgPr>
+        <a:solidFill>
+          <a:srgbClr val="1A1D21"/>
+        </a:solidFill>
+      </p:bgPr>
+    </p:bg>
+    <p:spTree>
+      <p:nvGrpSpPr>
+        <p:cNvPr id="150" name="Shape 150"/>
+        <p:cNvGrpSpPr/>
+        <p:nvPr/>
+      </p:nvGrpSpPr>
+      <p:grpSpPr>
+        <a:xfrm>
+          <a:off x="0" y="0"/>
+          <a:ext cx="0" cy="0"/>
+          <a:chOff x="0" y="0"/>
+          <a:chExt cx="0" cy="0"/>
+        </a:xfrm>
+      </p:grpSpPr>
+      <p:pic>
+        <p:nvPicPr>
+          <p:cNvPr descr="image.png" id="151" name="Google Shape;151;p19"/>
+          <p:cNvPicPr preferRelativeResize="0"/>
+          <p:nvPr/>
+        </p:nvPicPr>
+        <p:blipFill rotWithShape="1">
+          <a:blip r:embed="rId3">
+            <a:alphaModFix/>
+          </a:blip>
+          <a:srcRect b="0" l="0" r="0" t="0"/>
+          <a:stretch/>
+        </p:blipFill>
+        <p:spPr>
+          <a:xfrm>
+            <a:off x="0" y="0"/>
+            <a:ext cx="12192000" cy="6858000"/>
+          </a:xfrm>
+          <a:prstGeom prst="rect">
+            <a:avLst/>
+          </a:prstGeom>
+          <a:noFill/>
+          <a:ln>
+            <a:noFill/>
+          </a:ln>
+        </p:spPr>
+      </p:pic>
+      <p:sp>
+        <p:nvSpPr>
+          <p:cNvPr id="152" name="Google Shape;152;p19"/>
+          <p:cNvSpPr txBox="1"/>
+          <p:nvPr/>
+        </p:nvSpPr>
+        <p:spPr>
+          <a:xfrm>
+            <a:off x="2700575" y="2562225"/>
+            <a:ext cx="6790800" cy="923400"/>
+          </a:xfrm>
+          <a:prstGeom prst="rect">
+            <a:avLst/>
+          </a:prstGeom>
+          <a:noFill/>
+          <a:ln>
+            <a:noFill/>
+          </a:ln>
+        </p:spPr>
+        <p:txBody>
+          <a:bodyPr anchorCtr="0" anchor="t" bIns="0" lIns="0" spcFirstLastPara="1" rIns="0" wrap="square" tIns="0">
+            <a:spAutoFit/>
+          </a:bodyPr>
+          <a:lstStyle/>
+          <a:p>
+            <a:pPr indent="0" lvl="0" marL="0" marR="0" rtl="0" algn="ctr">
+              <a:spcBef>
+                <a:spcPts val="0"/>
+              </a:spcBef>
+              <a:spcAft>
+                <a:spcPts val="0"/>
+              </a:spcAft>
+              <a:buNone/>
+            </a:pPr>
+            <a:r>
+              <a:rPr b="0" i="0" lang="en-US" sz="6000" u="none" cap="none" strike="noStrike">
+                <a:solidFill>
+                  <a:srgbClr val="FFFFFF"/>
+                </a:solidFill>
+                <a:latin typeface="Inter ExtraBold"/>
+                <a:ea typeface="Inter ExtraBold"/>
+                <a:cs typeface="Inter ExtraBold"/>
+                <a:sym typeface="Inter ExtraBold"/>
+              </a:rPr>
+              <a:t>BIM </a:t>
+            </a:r>
+            <a:r>
+              <a:rPr b="0" i="0" lang="en-US" sz="6000" u="none" cap="none" strike="noStrike">
+                <a:solidFill>
+                  <a:srgbClr val="0696D7"/>
+                </a:solidFill>
+                <a:latin typeface="Inter ExtraBold"/>
+                <a:ea typeface="Inter ExtraBold"/>
+                <a:cs typeface="Inter ExtraBold"/>
+                <a:sym typeface="Inter ExtraBold"/>
+              </a:rPr>
+              <a:t>&amp;&amp;</a:t>
+            </a:r>
+            <a:r>
+              <a:rPr b="0" i="0" lang="en-US" sz="6000" u="none" cap="none" strike="noStrike">
+                <a:solidFill>
+                  <a:srgbClr val="FFFFFF"/>
+                </a:solidFill>
+                <a:latin typeface="Inter ExtraBold"/>
+                <a:ea typeface="Inter ExtraBold"/>
+                <a:cs typeface="Inter ExtraBold"/>
+                <a:sym typeface="Inter ExtraBold"/>
+              </a:rPr>
+              <a:t> YOU</a:t>
+            </a:r>
+            <a:endParaRPr/>
+          </a:p>
+        </p:txBody>
+      </p:sp>
+      <p:sp>
+        <p:nvSpPr>
+          <p:cNvPr id="153" name="Google Shape;153;p19"/>
+          <p:cNvSpPr txBox="1"/>
+          <p:nvPr/>
+        </p:nvSpPr>
+        <p:spPr>
+          <a:xfrm>
+            <a:off x="2459249" y="3695975"/>
+            <a:ext cx="7273500" cy="346200"/>
+          </a:xfrm>
+          <a:prstGeom prst="rect">
+            <a:avLst/>
+          </a:prstGeom>
+          <a:noFill/>
+          <a:ln>
+            <a:noFill/>
+          </a:ln>
+        </p:spPr>
+        <p:txBody>
+          <a:bodyPr anchorCtr="0" anchor="t" bIns="0" lIns="0" spcFirstLastPara="1" rIns="0" wrap="square" tIns="0">
+            <a:spAutoFit/>
+          </a:bodyPr>
+          <a:lstStyle/>
+          <a:p>
+            <a:pPr indent="0" lvl="0" marL="0" marR="0" rtl="0" algn="ctr">
+              <a:lnSpc>
+                <a:spcPct val="150000"/>
+              </a:lnSpc>
+              <a:spcBef>
+                <a:spcPts val="0"/>
+              </a:spcBef>
+              <a:spcAft>
+                <a:spcPts val="0"/>
+              </a:spcAft>
+              <a:buNone/>
+            </a:pPr>
+            <a:r>
+              <a:rPr b="0" i="0" lang="en-US" sz="2250" u="none" cap="none" strike="noStrike">
+                <a:solidFill>
+                  <a:srgbClr val="0696D7"/>
+                </a:solidFill>
+                <a:latin typeface="Inter"/>
+                <a:ea typeface="Inter"/>
+                <a:cs typeface="Inter"/>
+                <a:sym typeface="Inter"/>
+              </a:rPr>
+              <a:t>Episode </a:t>
+            </a:r>
+            <a:r>
+              <a:rPr lang="en-US" sz="2250">
+                <a:solidFill>
+                  <a:srgbClr val="0696D7"/>
+                </a:solidFill>
+                <a:latin typeface="Inter"/>
+                <a:ea typeface="Inter"/>
+                <a:cs typeface="Inter"/>
+                <a:sym typeface="Inter"/>
+              </a:rPr>
+              <a:t>01</a:t>
+            </a:r>
+            <a:r>
+              <a:rPr b="0" i="0" lang="en-US" sz="2250" u="none" cap="none" strike="noStrike">
+                <a:solidFill>
+                  <a:srgbClr val="0696D7"/>
+                </a:solidFill>
+                <a:latin typeface="Inter"/>
+                <a:ea typeface="Inter"/>
+                <a:cs typeface="Inter"/>
+                <a:sym typeface="Inter"/>
+              </a:rPr>
+              <a:t>: </a:t>
+            </a:r>
+            <a:r>
+              <a:rPr lang="en-US" sz="2250">
+                <a:solidFill>
+                  <a:srgbClr val="0696D7"/>
+                </a:solidFill>
+                <a:latin typeface="Inter"/>
+                <a:ea typeface="Inter"/>
+                <a:cs typeface="Inter"/>
+                <a:sym typeface="Inter"/>
+              </a:rPr>
+              <a:t>Creating a Coordination View</a:t>
+            </a:r>
+            <a:endParaRPr/>
+          </a:p>
+        </p:txBody>
+      </p:sp>
+    </p:spTree>
+  </p:cSld>
+  <p:clrMapOvr>
+    <a:masterClrMapping/>
+  </p:clrMapOvr>
+</p:sld>
+</file>
+
+<file path=ppt/slides/slide8.xml><?xml version="1.0" encoding="utf-8"?>
+<p:sld xmlns:a="http://schemas.openxmlformats.org/drawingml/2006/main" xmlns:r="http://schemas.openxmlformats.org/officeDocument/2006/relationships" xmlns:mc="http://schemas.openxmlformats.org/markup-compatibility/2006" xmlns:mv="urn:schemas-microsoft-com:mac:vml" xmlns:p="http://schemas.openxmlformats.org/presentationml/2006/main" xmlns:c="http://schemas.openxmlformats.org/drawingml/2006/chart" xmlns:dgm="http://schemas.openxmlformats.org/drawingml/2006/diagram" xmlns:o="urn:schemas-microsoft-com:office:office" xmlns:v="urn:schemas-microsoft-com:vml" xmlns:pvml="urn:schemas-microsoft-com:office:powerpoint" xmlns:com="http://schemas.openxmlformats.org/drawingml/2006/compatibility" xmlns:p14="http://schemas.microsoft.com/office/powerpoint/2010/main" xmlns:p15="http://schemas.microsoft.com/office/powerpoint/2012/main" xmlns:ahyp="http://schemas.microsoft.com/office/drawing/2018/hyperlinkcolor">
+  <p:cSld>
+    <p:bg>
+      <p:bgPr>
+        <a:solidFill>
+          <a:srgbClr val="1A1D21"/>
+        </a:solidFill>
+      </p:bgPr>
+    </p:bg>
+    <p:spTree>
+      <p:nvGrpSpPr>
+        <p:cNvPr id="157" name="Shape 157"/>
+        <p:cNvGrpSpPr/>
+        <p:nvPr/>
+      </p:nvGrpSpPr>
+      <p:grpSpPr>
+        <a:xfrm>
+          <a:off x="0" y="0"/>
+          <a:ext cx="0" cy="0"/>
+          <a:chOff x="0" y="0"/>
+          <a:chExt cx="0" cy="0"/>
+        </a:xfrm>
+      </p:grpSpPr>
+      <p:pic>
+        <p:nvPicPr>
+          <p:cNvPr descr="image.png" id="158" name="Google Shape;158;p20"/>
+          <p:cNvPicPr preferRelativeResize="0"/>
+          <p:nvPr/>
+        </p:nvPicPr>
+        <p:blipFill rotWithShape="1">
+          <a:blip r:embed="rId3">
+            <a:alphaModFix/>
+          </a:blip>
+          <a:srcRect b="0" l="0" r="0" t="0"/>
+          <a:stretch/>
+        </p:blipFill>
+        <p:spPr>
+          <a:xfrm>
+            <a:off x="0" y="0"/>
+            <a:ext cx="12192000" cy="6858000"/>
+          </a:xfrm>
+          <a:prstGeom prst="rect">
+            <a:avLst/>
+          </a:prstGeom>
+          <a:noFill/>
+          <a:ln>
+            <a:noFill/>
+          </a:ln>
+        </p:spPr>
+      </p:pic>
+      <p:sp>
+        <p:nvSpPr>
+          <p:cNvPr id="159" name="Google Shape;159;p20"/>
+          <p:cNvSpPr txBox="1"/>
+          <p:nvPr/>
+        </p:nvSpPr>
+        <p:spPr>
+          <a:xfrm>
+            <a:off x="866775" y="1952625"/>
+            <a:ext cx="4991100" cy="634800"/>
+          </a:xfrm>
+          <a:prstGeom prst="rect">
+            <a:avLst/>
+          </a:prstGeom>
+          <a:noFill/>
+          <a:ln>
+            <a:noFill/>
+          </a:ln>
+        </p:spPr>
+        <p:txBody>
+          <a:bodyPr anchorCtr="0" anchor="t" bIns="0" lIns="0" spcFirstLastPara="1" rIns="0" wrap="square" tIns="0">
+            <a:spAutoFit/>
+          </a:bodyPr>
+          <a:lstStyle/>
+          <a:p>
+            <a:pPr indent="0" lvl="0" marL="0" marR="0" rtl="0" algn="l">
+              <a:lnSpc>
+                <a:spcPct val="150000"/>
+              </a:lnSpc>
+              <a:spcBef>
+                <a:spcPts val="0"/>
+              </a:spcBef>
+              <a:spcAft>
+                <a:spcPts val="0"/>
+              </a:spcAft>
+              <a:buNone/>
+            </a:pPr>
+            <a:r>
+              <a:rPr b="1" i="0" lang="en-US" sz="1650" u="none" cap="none" strike="noStrike">
+                <a:solidFill>
+                  <a:srgbClr val="B5BAC1"/>
+                </a:solidFill>
+                <a:latin typeface="Inter"/>
+                <a:ea typeface="Inter"/>
+                <a:cs typeface="Inter"/>
+                <a:sym typeface="Inter"/>
+              </a:rPr>
+              <a:t>Tedious Repetition:</a:t>
+            </a:r>
+            <a:r>
+              <a:rPr b="0" i="0" lang="en-US" sz="1650" u="none" cap="none" strike="noStrike">
+                <a:solidFill>
+                  <a:srgbClr val="B5BAC1"/>
+                </a:solidFill>
+                <a:latin typeface="Inter"/>
+                <a:ea typeface="Inter"/>
+                <a:cs typeface="Inter"/>
+                <a:sym typeface="Inter"/>
+              </a:rPr>
+              <a:t> Manually </a:t>
+            </a:r>
+            <a:r>
+              <a:rPr lang="en-US" sz="1650">
+                <a:solidFill>
+                  <a:srgbClr val="B5BAC1"/>
+                </a:solidFill>
+                <a:latin typeface="Inter"/>
+                <a:ea typeface="Inter"/>
+                <a:cs typeface="Inter"/>
+                <a:sym typeface="Inter"/>
+              </a:rPr>
+              <a:t>creating</a:t>
+            </a:r>
+            <a:r>
+              <a:rPr lang="en-US" sz="1650">
+                <a:solidFill>
+                  <a:srgbClr val="B5BAC1"/>
+                </a:solidFill>
+                <a:latin typeface="Inter"/>
+                <a:ea typeface="Inter"/>
+                <a:cs typeface="Inter"/>
+                <a:sym typeface="Inter"/>
+              </a:rPr>
+              <a:t> and locking every view you open</a:t>
+            </a:r>
+            <a:endParaRPr/>
+          </a:p>
+        </p:txBody>
+      </p:sp>
+      <p:sp>
+        <p:nvSpPr>
+          <p:cNvPr id="160" name="Google Shape;160;p20"/>
+          <p:cNvSpPr txBox="1"/>
+          <p:nvPr/>
+        </p:nvSpPr>
+        <p:spPr>
+          <a:xfrm>
+            <a:off x="866775" y="3448050"/>
+            <a:ext cx="4991100" cy="634800"/>
+          </a:xfrm>
+          <a:prstGeom prst="rect">
+            <a:avLst/>
+          </a:prstGeom>
+          <a:noFill/>
+          <a:ln>
+            <a:noFill/>
+          </a:ln>
+        </p:spPr>
+        <p:txBody>
+          <a:bodyPr anchorCtr="0" anchor="t" bIns="0" lIns="0" spcFirstLastPara="1" rIns="0" wrap="square" tIns="0">
+            <a:spAutoFit/>
+          </a:bodyPr>
+          <a:lstStyle/>
+          <a:p>
+            <a:pPr indent="0" lvl="0" marL="0" marR="0" rtl="0" algn="l">
+              <a:lnSpc>
+                <a:spcPct val="150000"/>
+              </a:lnSpc>
+              <a:spcBef>
+                <a:spcPts val="0"/>
+              </a:spcBef>
+              <a:spcAft>
+                <a:spcPts val="0"/>
+              </a:spcAft>
+              <a:buNone/>
+            </a:pPr>
+            <a:r>
+              <a:rPr b="1" i="0" lang="en-US" sz="1650" u="none" cap="none" strike="noStrike">
+                <a:solidFill>
+                  <a:srgbClr val="B5BAC1"/>
+                </a:solidFill>
+                <a:latin typeface="Inter"/>
+                <a:ea typeface="Inter"/>
+                <a:cs typeface="Inter"/>
+                <a:sym typeface="Inter"/>
+              </a:rPr>
+              <a:t>Wasted Processing Time:</a:t>
+            </a:r>
+            <a:r>
+              <a:rPr b="0" i="0" lang="en-US" sz="1650" u="none" cap="none" strike="noStrike">
+                <a:solidFill>
+                  <a:srgbClr val="B5BAC1"/>
+                </a:solidFill>
+                <a:latin typeface="Inter"/>
+                <a:ea typeface="Inter"/>
+                <a:cs typeface="Inter"/>
+                <a:sym typeface="Inter"/>
+              </a:rPr>
+              <a:t> </a:t>
+            </a:r>
+            <a:r>
+              <a:rPr lang="en-US" sz="1650">
+                <a:solidFill>
+                  <a:srgbClr val="B5BAC1"/>
+                </a:solidFill>
+                <a:latin typeface="Inter"/>
+                <a:ea typeface="Inter"/>
+                <a:cs typeface="Inter"/>
+                <a:sym typeface="Inter"/>
+              </a:rPr>
+              <a:t>doing this for each model you open</a:t>
+            </a:r>
+            <a:endParaRPr/>
+          </a:p>
+        </p:txBody>
+      </p:sp>
+      <p:sp>
+        <p:nvSpPr>
+          <p:cNvPr id="161" name="Google Shape;161;p20"/>
+          <p:cNvSpPr txBox="1"/>
+          <p:nvPr/>
+        </p:nvSpPr>
+        <p:spPr>
+          <a:xfrm>
+            <a:off x="866775" y="4629150"/>
+            <a:ext cx="4991100" cy="1777800"/>
+          </a:xfrm>
+          <a:prstGeom prst="rect">
+            <a:avLst/>
+          </a:prstGeom>
+          <a:noFill/>
+          <a:ln>
+            <a:noFill/>
+          </a:ln>
+        </p:spPr>
+        <p:txBody>
+          <a:bodyPr anchorCtr="0" anchor="t" bIns="0" lIns="0" spcFirstLastPara="1" rIns="0" wrap="square" tIns="0">
+            <a:spAutoFit/>
+          </a:bodyPr>
+          <a:lstStyle/>
+          <a:p>
+            <a:pPr indent="0" lvl="0" marL="0" marR="0" rtl="0" algn="l">
+              <a:lnSpc>
+                <a:spcPct val="150000"/>
+              </a:lnSpc>
+              <a:spcBef>
+                <a:spcPts val="0"/>
+              </a:spcBef>
+              <a:spcAft>
+                <a:spcPts val="0"/>
+              </a:spcAft>
+              <a:buNone/>
+            </a:pPr>
+            <a:r>
+              <a:rPr b="1" i="0" lang="en-US" sz="1650" u="none" cap="none" strike="noStrike">
+                <a:solidFill>
+                  <a:srgbClr val="B5BAC1"/>
+                </a:solidFill>
+                <a:latin typeface="Inter"/>
+                <a:ea typeface="Inter"/>
+                <a:cs typeface="Inter"/>
+                <a:sym typeface="Inter"/>
+              </a:rPr>
+              <a:t>Human Error:</a:t>
+            </a:r>
+            <a:r>
+              <a:rPr b="0" i="0" lang="en-US" sz="1650" u="none" cap="none" strike="noStrike">
+                <a:solidFill>
+                  <a:srgbClr val="B5BAC1"/>
+                </a:solidFill>
+                <a:latin typeface="Inter"/>
+                <a:ea typeface="Inter"/>
+                <a:cs typeface="Inter"/>
+                <a:sym typeface="Inter"/>
+              </a:rPr>
+              <a:t> </a:t>
+            </a:r>
+            <a:r>
+              <a:rPr lang="en-US" sz="1650">
+                <a:solidFill>
+                  <a:srgbClr val="B5BAC1"/>
+                </a:solidFill>
+                <a:latin typeface="Inter"/>
+                <a:ea typeface="Inter"/>
+                <a:cs typeface="Inter"/>
+                <a:sym typeface="Inter"/>
+              </a:rPr>
+              <a:t>Sometimes not locking and other </a:t>
+            </a:r>
+            <a:r>
+              <a:rPr lang="en-US" sz="1650">
+                <a:solidFill>
+                  <a:srgbClr val="B5BAC1"/>
+                </a:solidFill>
+                <a:latin typeface="Inter"/>
+                <a:ea typeface="Inter"/>
+                <a:cs typeface="Inter"/>
+                <a:sym typeface="Inter"/>
+              </a:rPr>
+              <a:t>people</a:t>
+            </a:r>
+            <a:r>
+              <a:rPr lang="en-US" sz="1650">
+                <a:solidFill>
+                  <a:srgbClr val="B5BAC1"/>
+                </a:solidFill>
+                <a:latin typeface="Inter"/>
+                <a:ea typeface="Inter"/>
+                <a:cs typeface="Inter"/>
+                <a:sym typeface="Inter"/>
+              </a:rPr>
+              <a:t> start to edit it</a:t>
+            </a:r>
+            <a:br>
+              <a:rPr lang="en-US" sz="1650">
+                <a:solidFill>
+                  <a:srgbClr val="B5BAC1"/>
+                </a:solidFill>
+                <a:latin typeface="Inter"/>
+                <a:ea typeface="Inter"/>
+                <a:cs typeface="Inter"/>
+                <a:sym typeface="Inter"/>
+              </a:rPr>
+            </a:br>
+            <a:r>
+              <a:rPr lang="en-US" sz="1650">
+                <a:solidFill>
+                  <a:srgbClr val="B5BAC1"/>
+                </a:solidFill>
+                <a:latin typeface="Inter"/>
+                <a:ea typeface="Inter"/>
+                <a:cs typeface="Inter"/>
+                <a:sym typeface="Inter"/>
+              </a:rPr>
+              <a:t>Navisworks</a:t>
+            </a:r>
+            <a:br>
+              <a:rPr lang="en-US" sz="1650">
+                <a:solidFill>
+                  <a:srgbClr val="B5BAC1"/>
+                </a:solidFill>
+                <a:latin typeface="Inter"/>
+                <a:ea typeface="Inter"/>
+                <a:cs typeface="Inter"/>
+                <a:sym typeface="Inter"/>
+              </a:rPr>
+            </a:br>
+            <a:r>
+              <a:rPr lang="en-US" sz="1650">
+                <a:solidFill>
+                  <a:srgbClr val="B5BAC1"/>
+                </a:solidFill>
+                <a:latin typeface="Inter"/>
+                <a:ea typeface="Inter"/>
+                <a:cs typeface="Inter"/>
+                <a:sym typeface="Inter"/>
+              </a:rPr>
+              <a:t>Naviswork</a:t>
+            </a:r>
+            <a:br>
+              <a:rPr lang="en-US" sz="1650">
+                <a:solidFill>
+                  <a:srgbClr val="B5BAC1"/>
+                </a:solidFill>
+                <a:latin typeface="Inter"/>
+                <a:ea typeface="Inter"/>
+                <a:cs typeface="Inter"/>
+                <a:sym typeface="Inter"/>
+              </a:rPr>
+            </a:br>
+            <a:r>
+              <a:rPr lang="en-US" sz="1650">
+                <a:solidFill>
+                  <a:srgbClr val="B5BAC1"/>
+                </a:solidFill>
+                <a:latin typeface="Inter"/>
+                <a:ea typeface="Inter"/>
+                <a:cs typeface="Inter"/>
+                <a:sym typeface="Inter"/>
+              </a:rPr>
+              <a:t>Navisworks.</a:t>
+            </a:r>
+            <a:endParaRPr/>
+          </a:p>
+        </p:txBody>
+      </p:sp>
+      <p:sp>
+        <p:nvSpPr>
+          <p:cNvPr id="162" name="Google Shape;162;p20"/>
+          <p:cNvSpPr txBox="1"/>
+          <p:nvPr/>
+        </p:nvSpPr>
+        <p:spPr>
+          <a:xfrm>
+            <a:off x="581025" y="1971675"/>
+            <a:ext cx="95400" cy="184800"/>
+          </a:xfrm>
+          <a:prstGeom prst="rect">
+            <a:avLst/>
+          </a:prstGeom>
+          <a:noFill/>
+          <a:ln>
+            <a:noFill/>
+          </a:ln>
+        </p:spPr>
+        <p:txBody>
+          <a:bodyPr anchorCtr="0" anchor="t" bIns="0" lIns="0" spcFirstLastPara="1" rIns="0" wrap="square" tIns="0">
+            <a:spAutoFit/>
+          </a:bodyPr>
+          <a:lstStyle/>
+          <a:p>
+            <a:pPr indent="0" lvl="0" marL="0" marR="0" rtl="0" algn="l">
+              <a:lnSpc>
+                <a:spcPct val="150000"/>
+              </a:lnSpc>
+              <a:spcBef>
+                <a:spcPts val="0"/>
+              </a:spcBef>
+              <a:spcAft>
+                <a:spcPts val="0"/>
+              </a:spcAft>
+              <a:buNone/>
+            </a:pPr>
+            <a:r>
+              <a:rPr b="0" i="0" lang="en-US" sz="1200" u="none" cap="none" strike="noStrike">
+                <a:solidFill>
+                  <a:srgbClr val="0696D7"/>
+                </a:solidFill>
+                <a:latin typeface="Inter"/>
+                <a:ea typeface="Inter"/>
+                <a:cs typeface="Inter"/>
+                <a:sym typeface="Inter"/>
+              </a:rPr>
+              <a:t>■</a:t>
+            </a:r>
+            <a:endParaRPr/>
+          </a:p>
+        </p:txBody>
+      </p:sp>
+      <p:sp>
+        <p:nvSpPr>
+          <p:cNvPr id="163" name="Google Shape;163;p20"/>
+          <p:cNvSpPr txBox="1"/>
+          <p:nvPr/>
+        </p:nvSpPr>
+        <p:spPr>
+          <a:xfrm>
+            <a:off x="581025" y="3467100"/>
+            <a:ext cx="95400" cy="184800"/>
+          </a:xfrm>
+          <a:prstGeom prst="rect">
+            <a:avLst/>
+          </a:prstGeom>
+          <a:noFill/>
+          <a:ln>
+            <a:noFill/>
+          </a:ln>
+        </p:spPr>
+        <p:txBody>
+          <a:bodyPr anchorCtr="0" anchor="t" bIns="0" lIns="0" spcFirstLastPara="1" rIns="0" wrap="square" tIns="0">
+            <a:spAutoFit/>
+          </a:bodyPr>
+          <a:lstStyle/>
+          <a:p>
+            <a:pPr indent="0" lvl="0" marL="0" marR="0" rtl="0" algn="l">
+              <a:lnSpc>
+                <a:spcPct val="150000"/>
+              </a:lnSpc>
+              <a:spcBef>
+                <a:spcPts val="0"/>
+              </a:spcBef>
+              <a:spcAft>
+                <a:spcPts val="0"/>
+              </a:spcAft>
+              <a:buNone/>
+            </a:pPr>
+            <a:r>
+              <a:rPr b="0" i="0" lang="en-US" sz="1200" u="none" cap="none" strike="noStrike">
+                <a:solidFill>
+                  <a:srgbClr val="0696D7"/>
+                </a:solidFill>
+                <a:latin typeface="Inter"/>
+                <a:ea typeface="Inter"/>
+                <a:cs typeface="Inter"/>
+                <a:sym typeface="Inter"/>
+              </a:rPr>
+              <a:t>■</a:t>
+            </a:r>
+            <a:endParaRPr/>
+          </a:p>
+        </p:txBody>
+      </p:sp>
+      <p:sp>
+        <p:nvSpPr>
+          <p:cNvPr id="164" name="Google Shape;164;p20"/>
+          <p:cNvSpPr txBox="1"/>
+          <p:nvPr/>
+        </p:nvSpPr>
+        <p:spPr>
+          <a:xfrm>
+            <a:off x="581025" y="4648200"/>
+            <a:ext cx="95400" cy="184800"/>
+          </a:xfrm>
+          <a:prstGeom prst="rect">
+            <a:avLst/>
+          </a:prstGeom>
+          <a:noFill/>
+          <a:ln>
+            <a:noFill/>
+          </a:ln>
+        </p:spPr>
+        <p:txBody>
+          <a:bodyPr anchorCtr="0" anchor="t" bIns="0" lIns="0" spcFirstLastPara="1" rIns="0" wrap="square" tIns="0">
+            <a:spAutoFit/>
+          </a:bodyPr>
+          <a:lstStyle/>
+          <a:p>
+            <a:pPr indent="0" lvl="0" marL="0" marR="0" rtl="0" algn="l">
+              <a:lnSpc>
+                <a:spcPct val="150000"/>
+              </a:lnSpc>
+              <a:spcBef>
+                <a:spcPts val="0"/>
+              </a:spcBef>
+              <a:spcAft>
+                <a:spcPts val="0"/>
+              </a:spcAft>
+              <a:buNone/>
+            </a:pPr>
+            <a:r>
+              <a:rPr b="0" i="0" lang="en-US" sz="1200" u="none" cap="none" strike="noStrike">
+                <a:solidFill>
+                  <a:srgbClr val="0696D7"/>
+                </a:solidFill>
+                <a:latin typeface="Inter"/>
+                <a:ea typeface="Inter"/>
+                <a:cs typeface="Inter"/>
+                <a:sym typeface="Inter"/>
+              </a:rPr>
+              <a:t>■</a:t>
+            </a:r>
+            <a:endParaRPr/>
+          </a:p>
+        </p:txBody>
+      </p:sp>
+      <p:sp>
+        <p:nvSpPr>
+          <p:cNvPr id="165" name="Google Shape;165;p20"/>
+          <p:cNvSpPr txBox="1"/>
+          <p:nvPr/>
+        </p:nvSpPr>
+        <p:spPr>
+          <a:xfrm>
+            <a:off x="581025" y="581025"/>
+            <a:ext cx="11581500" cy="519600"/>
+          </a:xfrm>
+          <a:prstGeom prst="rect">
+            <a:avLst/>
+          </a:prstGeom>
+          <a:noFill/>
+          <a:ln>
+            <a:noFill/>
+          </a:ln>
+        </p:spPr>
+        <p:txBody>
+          <a:bodyPr anchorCtr="0" anchor="t" bIns="0" lIns="0" spcFirstLastPara="1" rIns="0" wrap="square" tIns="0">
+            <a:spAutoFit/>
+          </a:bodyPr>
+          <a:lstStyle/>
+          <a:p>
+            <a:pPr indent="0" lvl="0" marL="0" marR="0" rtl="0" algn="l">
+              <a:spcBef>
+                <a:spcPts val="0"/>
+              </a:spcBef>
+              <a:spcAft>
+                <a:spcPts val="0"/>
+              </a:spcAft>
+              <a:buNone/>
+            </a:pPr>
+            <a:r>
+              <a:rPr b="0" i="0" lang="en-US" sz="3375" u="none" cap="none" strike="noStrike">
+                <a:solidFill>
+                  <a:srgbClr val="FFFFFF"/>
+                </a:solidFill>
+                <a:latin typeface="Inter ExtraBold"/>
+                <a:ea typeface="Inter ExtraBold"/>
+                <a:cs typeface="Inter ExtraBold"/>
+                <a:sym typeface="Inter ExtraBold"/>
+              </a:rPr>
+              <a:t>The Daily </a:t>
+            </a:r>
+            <a:r>
+              <a:rPr b="0" i="0" lang="en-US" sz="3375" u="none" cap="none" strike="noStrike">
+                <a:solidFill>
+                  <a:srgbClr val="0696D7"/>
+                </a:solidFill>
+                <a:latin typeface="Inter ExtraBold"/>
+                <a:ea typeface="Inter ExtraBold"/>
+                <a:cs typeface="Inter ExtraBold"/>
+                <a:sym typeface="Inter ExtraBold"/>
+              </a:rPr>
+              <a:t>Bottleneck</a:t>
+            </a:r>
+            <a:endParaRPr/>
+          </a:p>
+        </p:txBody>
+      </p:sp>
+      <p:pic>
+        <p:nvPicPr>
+          <p:cNvPr id="166" name="Google Shape;166;p20"/>
+          <p:cNvPicPr preferRelativeResize="0"/>
+          <p:nvPr/>
+        </p:nvPicPr>
+        <p:blipFill>
+          <a:blip r:embed="rId4">
+            <a:alphaModFix/>
+          </a:blip>
+          <a:stretch>
+            <a:fillRect/>
+          </a:stretch>
+        </p:blipFill>
+        <p:spPr>
+          <a:xfrm>
+            <a:off x="6327150" y="1454221"/>
+            <a:ext cx="5268925" cy="3809725"/>
+          </a:xfrm>
+          <a:prstGeom prst="rect">
+            <a:avLst/>
+          </a:prstGeom>
+          <a:noFill/>
+          <a:ln>
+            <a:noFill/>
+          </a:ln>
+        </p:spPr>
+      </p:pic>
+    </p:spTree>
+  </p:cSld>
+  <p:clrMapOvr>
+    <a:masterClrMapping/>
+  </p:clrMapOvr>
+</p:sld>
+</file>
+
+<file path=ppt/slides/slide9.xml><?xml version="1.0" encoding="utf-8"?>
+<p:sld xmlns:a="http://schemas.openxmlformats.org/drawingml/2006/main" xmlns:r="http://schemas.openxmlformats.org/officeDocument/2006/relationships" xmlns:mc="http://schemas.openxmlformats.org/markup-compatibility/2006" xmlns:mv="urn:schemas-microsoft-com:mac:vml" xmlns:p="http://schemas.openxmlformats.org/presentationml/2006/main" xmlns:c="http://schemas.openxmlformats.org/drawingml/2006/chart" xmlns:dgm="http://schemas.openxmlformats.org/drawingml/2006/diagram" xmlns:o="urn:schemas-microsoft-com:office:office" xmlns:v="urn:schemas-microsoft-com:vml" xmlns:pvml="urn:schemas-microsoft-com:office:powerpoint" xmlns:com="http://schemas.openxmlformats.org/drawingml/2006/compatibility" xmlns:p14="http://schemas.microsoft.com/office/powerpoint/2010/main" xmlns:p15="http://schemas.microsoft.com/office/powerpoint/2012/main" xmlns:ahyp="http://schemas.microsoft.com/office/drawing/2018/hyperlinkcolor">
+  <p:cSld>
+    <p:bg>
+      <p:bgPr>
+        <a:solidFill>
+          <a:srgbClr val="1A1D21"/>
+        </a:solidFill>
+      </p:bgPr>
+    </p:bg>
+    <p:spTree>
+      <p:nvGrpSpPr>
+        <p:cNvPr id="170" name="Shape 170"/>
+        <p:cNvGrpSpPr/>
+        <p:nvPr/>
+      </p:nvGrpSpPr>
+      <p:grpSpPr>
+        <a:xfrm>
+          <a:off x="0" y="0"/>
+          <a:ext cx="0" cy="0"/>
+          <a:chOff x="0" y="0"/>
+          <a:chExt cx="0" cy="0"/>
+        </a:xfrm>
+      </p:grpSpPr>
+      <p:pic>
+        <p:nvPicPr>
+          <p:cNvPr descr="image.png" id="171" name="Google Shape;171;p21"/>
+          <p:cNvPicPr preferRelativeResize="0"/>
+          <p:nvPr/>
+        </p:nvPicPr>
+        <p:blipFill rotWithShape="1">
+          <a:blip r:embed="rId3">
+            <a:alphaModFix/>
+          </a:blip>
+          <a:srcRect b="0" l="0" r="0" t="0"/>
+          <a:stretch/>
+        </p:blipFill>
+        <p:spPr>
+          <a:xfrm>
+            <a:off x="0" y="0"/>
+            <a:ext cx="12192000" cy="6858000"/>
+          </a:xfrm>
+          <a:prstGeom prst="rect">
+            <a:avLst/>
+          </a:prstGeom>
+          <a:noFill/>
+          <a:ln>
+            <a:noFill/>
+          </a:ln>
+        </p:spPr>
+      </p:pic>
+      <p:pic>
+        <p:nvPicPr>
+          <p:cNvPr descr="image.png" id="172" name="Google Shape;172;p21"/>
+          <p:cNvPicPr preferRelativeResize="0"/>
+          <p:nvPr/>
+        </p:nvPicPr>
+        <p:blipFill rotWithShape="1">
+          <a:blip r:embed="rId4">
+            <a:alphaModFix/>
+          </a:blip>
+          <a:srcRect b="0" l="0" r="0" t="0"/>
+          <a:stretch/>
+        </p:blipFill>
+        <p:spPr>
+          <a:xfrm>
+            <a:off x="581025" y="1914525"/>
+            <a:ext cx="3422600" cy="3933825"/>
+          </a:xfrm>
+          <a:prstGeom prst="rect">
+            <a:avLst/>
+          </a:prstGeom>
+          <a:noFill/>
+          <a:ln>
+            <a:noFill/>
+          </a:ln>
+        </p:spPr>
+      </p:pic>
+      <p:pic>
+        <p:nvPicPr>
+          <p:cNvPr descr="image.png" id="173" name="Google Shape;173;p21"/>
+          <p:cNvPicPr preferRelativeResize="0"/>
+          <p:nvPr/>
+        </p:nvPicPr>
+        <p:blipFill rotWithShape="1">
+          <a:blip r:embed="rId5">
+            <a:alphaModFix/>
+          </a:blip>
+          <a:srcRect b="0" l="0" r="0" t="0"/>
+          <a:stretch/>
+        </p:blipFill>
+        <p:spPr>
+          <a:xfrm>
+            <a:off x="4384625" y="1914525"/>
+            <a:ext cx="3422600" cy="3933825"/>
+          </a:xfrm>
+          <a:prstGeom prst="rect">
+            <a:avLst/>
+          </a:prstGeom>
+          <a:noFill/>
+          <a:ln>
+            <a:noFill/>
+          </a:ln>
+        </p:spPr>
+      </p:pic>
+      <p:pic>
+        <p:nvPicPr>
+          <p:cNvPr descr="image.png" id="174" name="Google Shape;174;p21"/>
+          <p:cNvPicPr preferRelativeResize="0"/>
+          <p:nvPr/>
+        </p:nvPicPr>
+        <p:blipFill rotWithShape="1">
+          <a:blip r:embed="rId4">
+            <a:alphaModFix/>
+          </a:blip>
+          <a:srcRect b="0" l="0" r="0" t="0"/>
+          <a:stretch/>
+        </p:blipFill>
+        <p:spPr>
+          <a:xfrm>
+            <a:off x="8188225" y="1914525"/>
+            <a:ext cx="3422600" cy="3933825"/>
+          </a:xfrm>
+          <a:prstGeom prst="rect">
+            <a:avLst/>
+          </a:prstGeom>
+          <a:noFill/>
+          <a:ln>
+            <a:noFill/>
+          </a:ln>
+        </p:spPr>
+      </p:pic>
+      <p:sp>
+        <p:nvSpPr>
+          <p:cNvPr id="175" name="Google Shape;175;p21"/>
+          <p:cNvSpPr txBox="1"/>
+          <p:nvPr/>
+        </p:nvSpPr>
+        <p:spPr>
+          <a:xfrm>
+            <a:off x="876300" y="2990850"/>
+            <a:ext cx="2832000" cy="346200"/>
+          </a:xfrm>
+          <a:prstGeom prst="rect">
+            <a:avLst/>
+          </a:prstGeom>
+          <a:noFill/>
+          <a:ln>
+            <a:noFill/>
+          </a:ln>
+        </p:spPr>
+        <p:txBody>
+          <a:bodyPr anchorCtr="0" anchor="t" bIns="0" lIns="0" spcFirstLastPara="1" rIns="0" wrap="square" tIns="0">
+            <a:spAutoFit/>
+          </a:bodyPr>
+          <a:lstStyle/>
+          <a:p>
+            <a:pPr indent="0" lvl="0" marL="0" marR="0" rtl="0" algn="l">
+              <a:spcBef>
+                <a:spcPts val="0"/>
+              </a:spcBef>
+              <a:spcAft>
+                <a:spcPts val="0"/>
+              </a:spcAft>
+              <a:buNone/>
+            </a:pPr>
+            <a:r>
+              <a:rPr b="0" i="0" lang="en-US" sz="2250" u="none" cap="none" strike="noStrike">
+                <a:solidFill>
+                  <a:srgbClr val="FFFFFF"/>
+                </a:solidFill>
+                <a:latin typeface="Inter SemiBold"/>
+                <a:ea typeface="Inter SemiBold"/>
+                <a:cs typeface="Inter SemiBold"/>
+                <a:sym typeface="Inter SemiBold"/>
+              </a:rPr>
+              <a:t>1. </a:t>
+            </a:r>
+            <a:r>
+              <a:rPr lang="en-US" sz="2250">
+                <a:solidFill>
+                  <a:srgbClr val="FFFFFF"/>
+                </a:solidFill>
+                <a:latin typeface="Inter SemiBold"/>
+                <a:ea typeface="Inter SemiBold"/>
+                <a:cs typeface="Inter SemiBold"/>
+                <a:sym typeface="Inter SemiBold"/>
+              </a:rPr>
+              <a:t>Dynamo Graph</a:t>
+            </a:r>
+            <a:endParaRPr/>
+          </a:p>
+        </p:txBody>
+      </p:sp>
+      <p:sp>
+        <p:nvSpPr>
+          <p:cNvPr id="176" name="Google Shape;176;p21"/>
+          <p:cNvSpPr txBox="1"/>
+          <p:nvPr/>
+        </p:nvSpPr>
+        <p:spPr>
+          <a:xfrm>
+            <a:off x="876300" y="3476625"/>
+            <a:ext cx="2832000" cy="634800"/>
+          </a:xfrm>
+          <a:prstGeom prst="rect">
+            <a:avLst/>
+          </a:prstGeom>
+          <a:noFill/>
+          <a:ln>
+            <a:noFill/>
+          </a:ln>
+        </p:spPr>
+        <p:txBody>
+          <a:bodyPr anchorCtr="0" anchor="t" bIns="0" lIns="0" spcFirstLastPara="1" rIns="0" wrap="square" tIns="0">
+            <a:spAutoFit/>
+          </a:bodyPr>
+          <a:lstStyle/>
+          <a:p>
+            <a:pPr indent="0" lvl="0" marL="0" marR="0" rtl="0" algn="l">
+              <a:lnSpc>
+                <a:spcPct val="150000"/>
+              </a:lnSpc>
+              <a:spcBef>
+                <a:spcPts val="0"/>
+              </a:spcBef>
+              <a:spcAft>
+                <a:spcPts val="0"/>
+              </a:spcAft>
+              <a:buNone/>
+            </a:pPr>
+            <a:r>
+              <a:rPr lang="en-US" sz="1650">
+                <a:solidFill>
+                  <a:srgbClr val="B5BAC1"/>
+                </a:solidFill>
+                <a:latin typeface="Inter"/>
+                <a:ea typeface="Inter"/>
+                <a:cs typeface="Inter"/>
+                <a:sym typeface="Inter"/>
+              </a:rPr>
+              <a:t>Update the Name to Your Linking</a:t>
+            </a:r>
+            <a:endParaRPr/>
+          </a:p>
+        </p:txBody>
+      </p:sp>
+      <p:sp>
+        <p:nvSpPr>
+          <p:cNvPr id="177" name="Google Shape;177;p21"/>
+          <p:cNvSpPr txBox="1"/>
+          <p:nvPr/>
+        </p:nvSpPr>
+        <p:spPr>
+          <a:xfrm>
+            <a:off x="4679900" y="2990850"/>
+            <a:ext cx="2420400" cy="346200"/>
+          </a:xfrm>
+          <a:prstGeom prst="rect">
+            <a:avLst/>
+          </a:prstGeom>
+          <a:noFill/>
+          <a:ln>
+            <a:noFill/>
+          </a:ln>
+        </p:spPr>
+        <p:txBody>
+          <a:bodyPr anchorCtr="0" anchor="t" bIns="0" lIns="0" spcFirstLastPara="1" rIns="0" wrap="square" tIns="0">
+            <a:spAutoFit/>
+          </a:bodyPr>
+          <a:lstStyle/>
+          <a:p>
+            <a:pPr indent="0" lvl="0" marL="0" marR="0" rtl="0" algn="l">
+              <a:spcBef>
+                <a:spcPts val="0"/>
+              </a:spcBef>
+              <a:spcAft>
+                <a:spcPts val="0"/>
+              </a:spcAft>
+              <a:buNone/>
+            </a:pPr>
+            <a:r>
+              <a:rPr b="0" i="0" lang="en-US" sz="2250" u="none" cap="none" strike="noStrike">
+                <a:solidFill>
+                  <a:srgbClr val="FFFFFF"/>
+                </a:solidFill>
+                <a:latin typeface="Inter SemiBold"/>
+                <a:ea typeface="Inter SemiBold"/>
+                <a:cs typeface="Inter SemiBold"/>
+                <a:sym typeface="Inter SemiBold"/>
+              </a:rPr>
+              <a:t>2. </a:t>
+            </a:r>
+            <a:r>
+              <a:rPr lang="en-US" sz="2250">
+                <a:solidFill>
+                  <a:srgbClr val="FFFFFF"/>
+                </a:solidFill>
+                <a:latin typeface="Inter SemiBold"/>
+                <a:ea typeface="Inter SemiBold"/>
+                <a:cs typeface="Inter SemiBold"/>
+                <a:sym typeface="Inter SemiBold"/>
+              </a:rPr>
+              <a:t>Run the script</a:t>
+            </a:r>
+            <a:endParaRPr/>
+          </a:p>
+        </p:txBody>
+      </p:sp>
+      <p:sp>
+        <p:nvSpPr>
+          <p:cNvPr id="178" name="Google Shape;178;p21"/>
+          <p:cNvSpPr txBox="1"/>
+          <p:nvPr/>
+        </p:nvSpPr>
+        <p:spPr>
+          <a:xfrm>
+            <a:off x="4679900" y="3476625"/>
+            <a:ext cx="2832000" cy="254100"/>
+          </a:xfrm>
+          <a:prstGeom prst="rect">
+            <a:avLst/>
+          </a:prstGeom>
+          <a:noFill/>
+          <a:ln>
+            <a:noFill/>
+          </a:ln>
+        </p:spPr>
+        <p:txBody>
+          <a:bodyPr anchorCtr="0" anchor="t" bIns="0" lIns="0" spcFirstLastPara="1" rIns="0" wrap="square" tIns="0">
+            <a:spAutoFit/>
+          </a:bodyPr>
+          <a:lstStyle/>
+          <a:p>
+            <a:pPr indent="0" lvl="0" marL="0" marR="0" rtl="0" algn="l">
+              <a:lnSpc>
+                <a:spcPct val="150000"/>
+              </a:lnSpc>
+              <a:spcBef>
+                <a:spcPts val="0"/>
+              </a:spcBef>
+              <a:spcAft>
+                <a:spcPts val="0"/>
+              </a:spcAft>
+              <a:buNone/>
+            </a:pPr>
+            <a:r>
+              <a:rPr lang="en-US" sz="1650">
+                <a:solidFill>
+                  <a:srgbClr val="B5BAC1"/>
+                </a:solidFill>
+                <a:latin typeface="Inter"/>
+                <a:ea typeface="Inter"/>
+                <a:cs typeface="Inter"/>
+                <a:sym typeface="Inter"/>
+              </a:rPr>
+              <a:t>click on the run button</a:t>
+            </a:r>
+            <a:endParaRPr/>
+          </a:p>
+        </p:txBody>
+      </p:sp>
+      <p:sp>
+        <p:nvSpPr>
+          <p:cNvPr id="179" name="Google Shape;179;p21"/>
+          <p:cNvSpPr txBox="1"/>
+          <p:nvPr/>
+        </p:nvSpPr>
+        <p:spPr>
+          <a:xfrm>
+            <a:off x="8483500" y="2990850"/>
+            <a:ext cx="3060600" cy="346200"/>
+          </a:xfrm>
+          <a:prstGeom prst="rect">
+            <a:avLst/>
+          </a:prstGeom>
+          <a:noFill/>
+          <a:ln>
+            <a:noFill/>
+          </a:ln>
+        </p:spPr>
+        <p:txBody>
+          <a:bodyPr anchorCtr="0" anchor="t" bIns="0" lIns="0" spcFirstLastPara="1" rIns="0" wrap="square" tIns="0">
+            <a:spAutoFit/>
+          </a:bodyPr>
+          <a:lstStyle/>
+          <a:p>
+            <a:pPr indent="0" lvl="0" marL="0" marR="0" rtl="0" algn="l">
+              <a:spcBef>
+                <a:spcPts val="0"/>
+              </a:spcBef>
+              <a:spcAft>
+                <a:spcPts val="0"/>
+              </a:spcAft>
+              <a:buNone/>
+            </a:pPr>
+            <a:r>
+              <a:rPr b="0" i="0" lang="en-US" sz="2250" u="none" cap="none" strike="noStrike">
+                <a:solidFill>
+                  <a:srgbClr val="FFFFFF"/>
+                </a:solidFill>
+                <a:latin typeface="Inter SemiBold"/>
+                <a:ea typeface="Inter SemiBold"/>
+                <a:cs typeface="Inter SemiBold"/>
+                <a:sym typeface="Inter SemiBold"/>
+              </a:rPr>
+              <a:t>3. </a:t>
+            </a:r>
+            <a:r>
+              <a:rPr lang="en-US" sz="2250">
+                <a:solidFill>
+                  <a:srgbClr val="FFFFFF"/>
+                </a:solidFill>
+                <a:latin typeface="Inter SemiBold"/>
+                <a:ea typeface="Inter SemiBold"/>
+                <a:cs typeface="Inter SemiBold"/>
+                <a:sym typeface="Inter SemiBold"/>
+              </a:rPr>
+              <a:t>Check the result</a:t>
+            </a:r>
+            <a:endParaRPr/>
+          </a:p>
+        </p:txBody>
+      </p:sp>
+      <p:sp>
+        <p:nvSpPr>
+          <p:cNvPr id="180" name="Google Shape;180;p21"/>
+          <p:cNvSpPr txBox="1"/>
+          <p:nvPr/>
+        </p:nvSpPr>
+        <p:spPr>
+          <a:xfrm>
+            <a:off x="8483500" y="3476625"/>
+            <a:ext cx="2832000" cy="634800"/>
+          </a:xfrm>
+          <a:prstGeom prst="rect">
+            <a:avLst/>
+          </a:prstGeom>
+          <a:noFill/>
+          <a:ln>
+            <a:noFill/>
+          </a:ln>
+        </p:spPr>
+        <p:txBody>
+          <a:bodyPr anchorCtr="0" anchor="t" bIns="0" lIns="0" spcFirstLastPara="1" rIns="0" wrap="square" tIns="0">
+            <a:spAutoFit/>
+          </a:bodyPr>
+          <a:lstStyle/>
+          <a:p>
+            <a:pPr indent="0" lvl="0" marL="0" marR="0" rtl="0" algn="l">
+              <a:lnSpc>
+                <a:spcPct val="150000"/>
+              </a:lnSpc>
+              <a:spcBef>
+                <a:spcPts val="0"/>
+              </a:spcBef>
+              <a:spcAft>
+                <a:spcPts val="0"/>
+              </a:spcAft>
+              <a:buNone/>
+            </a:pPr>
+            <a:r>
+              <a:rPr lang="en-US" sz="1650">
+                <a:solidFill>
+                  <a:srgbClr val="B5BAC1"/>
+                </a:solidFill>
+                <a:latin typeface="Inter"/>
+                <a:ea typeface="Inter"/>
+                <a:cs typeface="Inter"/>
+                <a:sym typeface="Inter"/>
+              </a:rPr>
+              <a:t>check at least one revit model</a:t>
+            </a:r>
+            <a:endParaRPr/>
+          </a:p>
+        </p:txBody>
+      </p:sp>
+      <p:pic>
+        <p:nvPicPr>
+          <p:cNvPr descr="image.png" id="181" name="Google Shape;181;p21"/>
+          <p:cNvPicPr preferRelativeResize="0"/>
+          <p:nvPr/>
+        </p:nvPicPr>
+        <p:blipFill rotWithShape="1">
+          <a:blip r:embed="rId6">
+            <a:alphaModFix/>
+          </a:blip>
+          <a:srcRect b="0" l="0" r="0" t="0"/>
+          <a:stretch/>
+        </p:blipFill>
+        <p:spPr>
+          <a:xfrm>
+            <a:off x="876300" y="2324100"/>
+            <a:ext cx="476250" cy="381000"/>
+          </a:xfrm>
+          <a:prstGeom prst="rect">
+            <a:avLst/>
+          </a:prstGeom>
+          <a:noFill/>
+          <a:ln>
+            <a:noFill/>
+          </a:ln>
+        </p:spPr>
+      </p:pic>
+      <p:pic>
+        <p:nvPicPr>
+          <p:cNvPr descr="image.png" id="182" name="Google Shape;182;p21"/>
+          <p:cNvPicPr preferRelativeResize="0"/>
+          <p:nvPr/>
+        </p:nvPicPr>
+        <p:blipFill rotWithShape="1">
+          <a:blip r:embed="rId7">
+            <a:alphaModFix/>
+          </a:blip>
+          <a:srcRect b="0" l="0" r="0" t="0"/>
+          <a:stretch/>
+        </p:blipFill>
+        <p:spPr>
+          <a:xfrm>
+            <a:off x="4679900" y="2324100"/>
+            <a:ext cx="428625" cy="381000"/>
+          </a:xfrm>
+          <a:prstGeom prst="rect">
+            <a:avLst/>
+          </a:prstGeom>
+          <a:noFill/>
+          <a:ln>
+            <a:noFill/>
+          </a:ln>
+        </p:spPr>
+      </p:pic>
+      <p:pic>
+        <p:nvPicPr>
+          <p:cNvPr descr="image.png" id="183" name="Google Shape;183;p21"/>
+          <p:cNvPicPr preferRelativeResize="0"/>
+          <p:nvPr/>
+        </p:nvPicPr>
+        <p:blipFill rotWithShape="1">
+          <a:blip r:embed="rId8">
+            <a:alphaModFix/>
+          </a:blip>
+          <a:srcRect b="0" l="0" r="0" t="0"/>
+          <a:stretch/>
+        </p:blipFill>
+        <p:spPr>
+          <a:xfrm>
+            <a:off x="8483500" y="2324100"/>
+            <a:ext cx="428625" cy="381000"/>
+          </a:xfrm>
+          <a:prstGeom prst="rect">
+            <a:avLst/>
+          </a:prstGeom>
+          <a:noFill/>
+          <a:ln>
+            <a:noFill/>
+          </a:ln>
+        </p:spPr>
+      </p:pic>
+      <p:sp>
+        <p:nvSpPr>
+          <p:cNvPr id="184" name="Google Shape;184;p21"/>
+          <p:cNvSpPr txBox="1"/>
+          <p:nvPr/>
+        </p:nvSpPr>
+        <p:spPr>
+          <a:xfrm>
+            <a:off x="581025" y="581025"/>
+            <a:ext cx="11581500" cy="519600"/>
+          </a:xfrm>
+          <a:prstGeom prst="rect">
+            <a:avLst/>
+          </a:prstGeom>
+          <a:noFill/>
+          <a:ln>
+            <a:noFill/>
+          </a:ln>
+        </p:spPr>
+        <p:txBody>
+          <a:bodyPr anchorCtr="0" anchor="t" bIns="0" lIns="0" spcFirstLastPara="1" rIns="0" wrap="square" tIns="0">
+            <a:spAutoFit/>
+          </a:bodyPr>
+          <a:lstStyle/>
+          <a:p>
+            <a:pPr indent="0" lvl="0" marL="0" marR="0" rtl="0" algn="l">
+              <a:spcBef>
+                <a:spcPts val="0"/>
+              </a:spcBef>
+              <a:spcAft>
+                <a:spcPts val="0"/>
+              </a:spcAft>
+              <a:buNone/>
+            </a:pPr>
+            <a:r>
+              <a:rPr b="0" i="0" lang="en-US" sz="3375" u="none" cap="none" strike="noStrike">
+                <a:solidFill>
+                  <a:srgbClr val="FFFFFF"/>
+                </a:solidFill>
+                <a:latin typeface="Inter ExtraBold"/>
+                <a:ea typeface="Inter ExtraBold"/>
+                <a:cs typeface="Inter ExtraBold"/>
+                <a:sym typeface="Inter ExtraBold"/>
+              </a:rPr>
+              <a:t>The VDC </a:t>
+            </a:r>
+            <a:r>
+              <a:rPr b="0" i="0" lang="en-US" sz="3375" u="none" cap="none" strike="noStrike">
+                <a:solidFill>
+                  <a:srgbClr val="71C238"/>
+                </a:solidFill>
+                <a:latin typeface="Inter ExtraBold"/>
+                <a:ea typeface="Inter ExtraBold"/>
+                <a:cs typeface="Inter ExtraBold"/>
+                <a:sym typeface="Inter ExtraBold"/>
+              </a:rPr>
+              <a:t>Workflow</a:t>
+            </a:r>
+            <a:endParaRPr/>
+          </a:p>
+        </p:txBody>
+      </p:sp>
+    </p:spTree>
+  </p:cSld>
+  <p:clrMapOvr>
+    <a:masterClrMapping/>
+  </p:clrMapOvr>
+</p:sld>
+</file>
+
 <file path=ppt/theme/theme1.xml><?xml version="1.0" encoding="utf-8"?>
+<a:theme xmlns:a="http://schemas.openxmlformats.org/drawingml/2006/main" xmlns:r="http://schemas.openxmlformats.org/officeDocument/2006/relationships">
+  <a:themeElements>
+    <a:clrScheme name="Default">
+      <a:dk1>
+        <a:srgbClr val="000000"/>
+      </a:dk1>
+      <a:lt1>
+        <a:srgbClr val="FFFFFF"/>
+      </a:lt1>
+      <a:dk2>
+        <a:srgbClr val="158158"/>
+      </a:dk2>
+      <a:lt2>
+        <a:srgbClr val="F3F3F3"/>
+      </a:lt2>
+      <a:accent1>
+        <a:srgbClr val="058DC7"/>
+      </a:accent1>
+      <a:accent2>
+        <a:srgbClr val="50B432"/>
+      </a:accent2>
+      <a:accent3>
+        <a:srgbClr val="ED561B"/>
+      </a:accent3>
+      <a:accent4>
+        <a:srgbClr val="EDEF00"/>
+      </a:accent4>
+      <a:accent5>
+        <a:srgbClr val="24CBE5"/>
+      </a:accent5>
+      <a:accent6>
+        <a:srgbClr val="64E572"/>
+      </a:accent6>
+      <a:hlink>
+        <a:srgbClr val="2200CC"/>
+      </a:hlink>
+      <a:folHlink>
+        <a:srgbClr val="551A8B"/>
+      </a:folHlink>
+    </a:clrScheme>
+    <a:fontScheme name="Office">
+      <a:majorFont>
+        <a:latin typeface="Arial"/>
+        <a:ea typeface=""/>
+        <a:cs typeface=""/>
+        <a:font script="Jpan" typeface="ＭＳ Ｐゴシック"/>
+        <a:font script="Hang" typeface="맑은 고딕"/>
+        <a:font script="Hans" typeface="宋体"/>
+        <a:font script="Hant" typeface="新細明體"/>
+        <a:font script="Arab" typeface="Times New Roman"/>
+        <a:font script="Hebr" typeface="Times New Roman"/>
+        <a:font script="Thai" typeface="Angsana New"/>
+        <a:font script="Ethi" typeface="Nyala"/>
+        <a:font script="Beng" typeface="Vrinda"/>
+        <a:font script="Gujr" typeface="Shruti"/>
+        <a:font script="Khmr" typeface="MoolBoran"/>
+        <a:font script="Knda" typeface="Tunga"/>
+        <a:font script="Guru" typeface="Raavi"/>
+        <a:font script="Cans" typeface="Euphemia"/>
+        <a:font script="Cher" typeface="Plantagenet Cherokee"/>
+        <a:font script="Yiii" typeface="Microsoft Yi Baiti"/>
+        <a:font script="Tibt" typeface="Microsoft Himalaya"/>
+        <a:font script="Thaa" typeface="MV Boli"/>
+        <a:font script="Deva" typeface="Mangal"/>
+        <a:font script="Telu" typeface="Gautami"/>
+        <a:font script="Taml" typeface="Latha"/>
+        <a:font script="Syrc" typeface="Estrangelo Edessa"/>
+        <a:font script="Orya" typeface="Kalinga"/>
+        <a:font script="Mlym" typeface="Kartika"/>
+        <a:font script="Laoo" typeface="DokChampa"/>
+        <a:font script="Sinh" typeface="Iskoola Pota"/>
+        <a:font script="Mong" typeface="Mongolian Baiti"/>
+        <a:font script="Viet" typeface="Times New Roman"/>
+        <a:font script="Uigh" typeface="Microsoft Uighur"/>
+        <a:font script="Geor" typeface="Sylfaen"/>
+      </a:majorFont>
+      <a:minorFont>
+        <a:latin typeface="Arial"/>
+        <a:ea typeface=""/>
+        <a:cs typeface=""/>
+        <a:font script="Jpan" typeface="ＭＳ Ｐゴシック"/>
+        <a:font script="Hang" typeface="맑은 고딕"/>
+        <a:font script="Hans" typeface="宋体"/>
+        <a:font script="Hant" typeface="新細明體"/>
+        <a:font script="Arab" typeface="Arial"/>
+        <a:font script="Hebr" typeface="Arial"/>
+        <a:font script="Thai" typeface="Cordia New"/>
+        <a:font script="Ethi" typeface="Nyala"/>
+        <a:font script="Beng" typeface="Vrinda"/>
+        <a:font script="Gujr" typeface="Shruti"/>
+        <a:font script="Khmr" typeface="DaunPenh"/>
+        <a:font script="Knda" typeface="Tunga"/>
+        <a:font script="Guru" typeface="Raavi"/>
+        <a:font script="Cans" typeface="Euphemia"/>
+        <a:font script="Cher" typeface="Plantagenet Cherokee"/>
+        <a:font script="Yiii" typeface="Microsoft Yi Baiti"/>
+        <a:font script="Tibt" typeface="Microsoft Himalaya"/>
+        <a:font script="Thaa" typeface="MV Boli"/>
+        <a:font script="Deva" typeface="Mangal"/>
+        <a:font script="Telu" typeface="Gautami"/>
+        <a:font script="Taml" typeface="Latha"/>
+        <a:font script="Syrc" typeface="Estrangelo Edessa"/>
+        <a:font script="Orya" typeface="Kalinga"/>
+        <a:font script="Mlym" typeface="Kartika"/>
+        <a:font script="Laoo" typeface="DokChampa"/>
+        <a:font script="Sinh" typeface="Iskoola Pota"/>
+        <a:font script="Mong" typeface="Mongolian Baiti"/>
+        <a:font script="Viet" typeface="Arial"/>
+        <a:font script="Uigh" typeface="Microsoft Uighur"/>
+        <a:font script="Geor" typeface="Sylfaen"/>
+      </a:minorFont>
+    </a:fontScheme>
+    <a:fmtScheme name="Office">
+      <a:fillStyleLst>
+        <a:solidFill>
+          <a:schemeClr val="phClr"/>
+        </a:solidFill>
+        <a:gradFill rotWithShape="1">
+          <a:gsLst>
+            <a:gs pos="0">
+              <a:schemeClr val="phClr">
+                <a:tint val="50000"/>
+                <a:satMod val="300000"/>
+              </a:schemeClr>
+            </a:gs>
+            <a:gs pos="35000">
+              <a:schemeClr val="phClr">
+                <a:tint val="37000"/>
+                <a:satMod val="300000"/>
+              </a:schemeClr>
+            </a:gs>
+            <a:gs pos="100000">
+              <a:schemeClr val="phClr">
+                <a:tint val="15000"/>
+                <a:satMod val="350000"/>
+              </a:schemeClr>
+            </a:gs>
+          </a:gsLst>
+          <a:lin ang="16200000" scaled="1"/>
+        </a:gradFill>
+        <a:gradFill rotWithShape="1">
+          <a:gsLst>
+            <a:gs pos="0">
+              <a:schemeClr val="phClr">
+                <a:tint val="100000"/>
+                <a:shade val="100000"/>
+                <a:satMod val="130000"/>
+              </a:schemeClr>
+            </a:gs>
+            <a:gs pos="100000">
+              <a:schemeClr val="phClr">
+                <a:tint val="50000"/>
+                <a:shade val="100000"/>
+                <a:satMod val="350000"/>
+              </a:schemeClr>
+            </a:gs>
+          </a:gsLst>
+          <a:lin ang="16200000" scaled="0"/>
+        </a:gradFill>
+      </a:fillStyleLst>
+      <a:lnStyleLst>
+        <a:ln w="9525" cap="flat" cmpd="sng" algn="ctr">
+          <a:solidFill>
+            <a:schemeClr val="phClr">
+              <a:shade val="95000"/>
+              <a:satMod val="105000"/>
+            </a:schemeClr>
+          </a:solidFill>
+          <a:prstDash val="solid"/>
+        </a:ln>
+        <a:ln w="25400" cap="flat" cmpd="sng" algn="ctr">
+          <a:solidFill>
+            <a:schemeClr val="phClr"/>
+          </a:solidFill>
+          <a:prstDash val="solid"/>
+        </a:ln>
+        <a:ln w="38100" cap="flat" cmpd="sng" algn="ctr">
+          <a:solidFill>
+            <a:schemeClr val="phClr"/>
+          </a:solidFill>
+          <a:prstDash val="solid"/>
+        </a:ln>
+      </a:lnStyleLst>
+      <a:effectStyleLst>
+        <a:effectStyle>
+          <a:effectLst>
+            <a:outerShdw blurRad="40000" dist="20000" dir="5400000" rotWithShape="0">
+              <a:srgbClr val="000000">
+                <a:alpha val="38000"/>
+              </a:srgbClr>
+            </a:outerShdw>
+          </a:effectLst>
+        </a:effectStyle>
+        <a:effectStyle>
+          <a:effectLst>
+            <a:outerShdw blurRad="40000" dist="23000" dir="5400000" rotWithShape="0">
+              <a:srgbClr val="000000">
+                <a:alpha val="35000"/>
+              </a:srgbClr>
+            </a:outerShdw>
+          </a:effectLst>
+        </a:effectStyle>
+        <a:effectStyle>
+          <a:effectLst>
+            <a:outerShdw blurRad="40000" dist="23000" dir="5400000" rotWithShape="0">
+              <a:srgbClr val="000000">
+                <a:alpha val="35000"/>
+              </a:srgbClr>
+            </a:outerShdw>
+          </a:effectLst>
+          <a:scene3d>
+            <a:camera prst="orthographicFront">
+              <a:rot lat="0" lon="0" rev="0"/>
+            </a:camera>
+            <a:lightRig rig="threePt" dir="t">
+              <a:rot lat="0" lon="0" rev="1200000"/>
+            </a:lightRig>
+          </a:scene3d>
+          <a:sp3d>
+            <a:bevelT w="63500" h="25400"/>
+          </a:sp3d>
+        </a:effectStyle>
+      </a:effectStyleLst>
+      <a:bgFillStyleLst>
+        <a:solidFill>
+          <a:schemeClr val="phClr"/>
+        </a:solidFill>
+        <a:gradFill rotWithShape="1">
+          <a:gsLst>
+            <a:gs pos="0">
+              <a:schemeClr val="phClr">
+                <a:tint val="40000"/>
+                <a:satMod val="350000"/>
+              </a:schemeClr>
+            </a:gs>
+            <a:gs pos="40000">
+              <a:schemeClr val="phClr">
+                <a:tint val="45000"/>
+                <a:shade val="99000"/>
+                <a:satMod val="350000"/>
+              </a:schemeClr>
+            </a:gs>
+            <a:gs pos="100000">
+              <a:schemeClr val="phClr">
+                <a:shade val="20000"/>
+                <a:satMod val="255000"/>
+              </a:schemeClr>
+            </a:gs>
+          </a:gsLst>
+          <a:path path="circle">
+            <a:fillToRect l="50000" t="-80000" r="50000" b="180000"/>
+          </a:path>
+        </a:gradFill>
+        <a:gradFill rotWithShape="1">
+          <a:gsLst>
+            <a:gs pos="0">
+              <a:schemeClr val="phClr">
+                <a:tint val="80000"/>
+                <a:satMod val="300000"/>
+              </a:schemeClr>
+            </a:gs>
+            <a:gs pos="100000">
+              <a:schemeClr val="phClr">
+                <a:shade val="30000"/>
+                <a:satMod val="200000"/>
+              </a:schemeClr>
+            </a:gs>
+          </a:gsLst>
+          <a:path path="circle">
+            <a:fillToRect l="50000" t="50000" r="50000" b="50000"/>
+          </a:path>
+        </a:gradFill>
+      </a:bgFillStyleLst>
+    </a:fmtScheme>
+  </a:themeElements>
+</a:theme>
+</file>
+
+<file path=ppt/theme/theme2.xml><?xml version="1.0" encoding="utf-8"?>
 <a:theme xmlns:a="http://schemas.openxmlformats.org/drawingml/2006/main" xmlns:r="http://schemas.openxmlformats.org/officeDocument/2006/relationships" name="Office Theme">
   <a:themeElements>
     <a:clrScheme name="Office">
@@ -13535,283 +17924,4 @@
     </a:fmtScheme>
   </a:themeElements>
 </a:theme>
-</file>
-
-<file path=ppt/theme/theme2.xml><?xml version="1.0" encoding="utf-8"?>
-<a:theme xmlns:a="http://schemas.openxmlformats.org/drawingml/2006/main" xmlns:r="http://schemas.openxmlformats.org/officeDocument/2006/relationships">
-  <a:themeElements>
-    <a:clrScheme name="Default">
-      <a:dk1>
-        <a:srgbClr val="000000"/>
-      </a:dk1>
-      <a:lt1>
-        <a:srgbClr val="FFFFFF"/>
-      </a:lt1>
-      <a:dk2>
-        <a:srgbClr val="158158"/>
-      </a:dk2>
-      <a:lt2>
-        <a:srgbClr val="F3F3F3"/>
-      </a:lt2>
-      <a:accent1>
-        <a:srgbClr val="058DC7"/>
-      </a:accent1>
-      <a:accent2>
-        <a:srgbClr val="50B432"/>
-      </a:accent2>
-      <a:accent3>
-        <a:srgbClr val="ED561B"/>
-      </a:accent3>
-      <a:accent4>
-        <a:srgbClr val="EDEF00"/>
-      </a:accent4>
-      <a:accent5>
-        <a:srgbClr val="24CBE5"/>
-      </a:accent5>
-      <a:accent6>
-        <a:srgbClr val="64E572"/>
-      </a:accent6>
-      <a:hlink>
-        <a:srgbClr val="2200CC"/>
-      </a:hlink>
-      <a:folHlink>
-        <a:srgbClr val="551A8B"/>
-      </a:folHlink>
-    </a:clrScheme>
-    <a:fontScheme name="Office">
-      <a:majorFont>
-        <a:latin typeface="Arial"/>
-        <a:ea typeface=""/>
-        <a:cs typeface=""/>
-        <a:font script="Jpan" typeface="ＭＳ Ｐゴシック"/>
-        <a:font script="Hang" typeface="맑은 고딕"/>
-        <a:font script="Hans" typeface="宋体"/>
-        <a:font script="Hant" typeface="新細明體"/>
-        <a:font script="Arab" typeface="Times New Roman"/>
-        <a:font script="Hebr" typeface="Times New Roman"/>
-        <a:font script="Thai" typeface="Angsana New"/>
-        <a:font script="Ethi" typeface="Nyala"/>
-        <a:font script="Beng" typeface="Vrinda"/>
-        <a:font script="Gujr" typeface="Shruti"/>
-        <a:font script="Khmr" typeface="MoolBoran"/>
-        <a:font script="Knda" typeface="Tunga"/>
-        <a:font script="Guru" typeface="Raavi"/>
-        <a:font script="Cans" typeface="Euphemia"/>
-        <a:font script="Cher" typeface="Plantagenet Cherokee"/>
-        <a:font script="Yiii" typeface="Microsoft Yi Baiti"/>
-        <a:font script="Tibt" typeface="Microsoft Himalaya"/>
-        <a:font script="Thaa" typeface="MV Boli"/>
-        <a:font script="Deva" typeface="Mangal"/>
-        <a:font script="Telu" typeface="Gautami"/>
-        <a:font script="Taml" typeface="Latha"/>
-        <a:font script="Syrc" typeface="Estrangelo Edessa"/>
-        <a:font script="Orya" typeface="Kalinga"/>
-        <a:font script="Mlym" typeface="Kartika"/>
-        <a:font script="Laoo" typeface="DokChampa"/>
-        <a:font script="Sinh" typeface="Iskoola Pota"/>
-        <a:font script="Mong" typeface="Mongolian Baiti"/>
-        <a:font script="Viet" typeface="Times New Roman"/>
-        <a:font script="Uigh" typeface="Microsoft Uighur"/>
-        <a:font script="Geor" typeface="Sylfaen"/>
-      </a:majorFont>
-      <a:minorFont>
-        <a:latin typeface="Arial"/>
-        <a:ea typeface=""/>
-        <a:cs typeface=""/>
-        <a:font script="Jpan" typeface="ＭＳ Ｐゴシック"/>
-        <a:font script="Hang" typeface="맑은 고딕"/>
-        <a:font script="Hans" typeface="宋体"/>
-        <a:font script="Hant" typeface="新細明體"/>
-        <a:font script="Arab" typeface="Arial"/>
-        <a:font script="Hebr" typeface="Arial"/>
-        <a:font script="Thai" typeface="Cordia New"/>
-        <a:font script="Ethi" typeface="Nyala"/>
-        <a:font script="Beng" typeface="Vrinda"/>
-        <a:font script="Gujr" typeface="Shruti"/>
-        <a:font script="Khmr" typeface="DaunPenh"/>
-        <a:font script="Knda" typeface="Tunga"/>
-        <a:font script="Guru" typeface="Raavi"/>
-        <a:font script="Cans" typeface="Euphemia"/>
-        <a:font script="Cher" typeface="Plantagenet Cherokee"/>
-        <a:font script="Yiii" typeface="Microsoft Yi Baiti"/>
-        <a:font script="Tibt" typeface="Microsoft Himalaya"/>
-        <a:font script="Thaa" typeface="MV Boli"/>
-        <a:font script="Deva" typeface="Mangal"/>
-        <a:font script="Telu" typeface="Gautami"/>
-        <a:font script="Taml" typeface="Latha"/>
-        <a:font script="Syrc" typeface="Estrangelo Edessa"/>
-        <a:font script="Orya" typeface="Kalinga"/>
-        <a:font script="Mlym" typeface="Kartika"/>
-        <a:font script="Laoo" typeface="DokChampa"/>
-        <a:font script="Sinh" typeface="Iskoola Pota"/>
-        <a:font script="Mong" typeface="Mongolian Baiti"/>
-        <a:font script="Viet" typeface="Arial"/>
-        <a:font script="Uigh" typeface="Microsoft Uighur"/>
-        <a:font script="Geor" typeface="Sylfaen"/>
-      </a:minorFont>
-    </a:fontScheme>
-    <a:fmtScheme name="Office">
-      <a:fillStyleLst>
-        <a:solidFill>
-          <a:schemeClr val="phClr"/>
-        </a:solidFill>
-        <a:gradFill rotWithShape="1">
-          <a:gsLst>
-            <a:gs pos="0">
-              <a:schemeClr val="phClr">
-                <a:tint val="50000"/>
-                <a:satMod val="300000"/>
-              </a:schemeClr>
-            </a:gs>
-            <a:gs pos="35000">
-              <a:schemeClr val="phClr">
-                <a:tint val="37000"/>
-                <a:satMod val="300000"/>
-              </a:schemeClr>
-            </a:gs>
-            <a:gs pos="100000">
-              <a:schemeClr val="phClr">
-                <a:tint val="15000"/>
-                <a:satMod val="350000"/>
-              </a:schemeClr>
-            </a:gs>
-          </a:gsLst>
-          <a:lin ang="16200000" scaled="1"/>
-        </a:gradFill>
-        <a:gradFill rotWithShape="1">
-          <a:gsLst>
-            <a:gs pos="0">
-              <a:schemeClr val="phClr">
-                <a:tint val="100000"/>
-                <a:shade val="100000"/>
-                <a:satMod val="130000"/>
-              </a:schemeClr>
-            </a:gs>
-            <a:gs pos="100000">
-              <a:schemeClr val="phClr">
-                <a:tint val="50000"/>
-                <a:shade val="100000"/>
-                <a:satMod val="350000"/>
-              </a:schemeClr>
-            </a:gs>
-          </a:gsLst>
-          <a:lin ang="16200000" scaled="0"/>
-        </a:gradFill>
-      </a:fillStyleLst>
-      <a:lnStyleLst>
-        <a:ln w="9525" cap="flat" cmpd="sng" algn="ctr">
-          <a:solidFill>
-            <a:schemeClr val="phClr">
-              <a:shade val="95000"/>
-              <a:satMod val="105000"/>
-            </a:schemeClr>
-          </a:solidFill>
-          <a:prstDash val="solid"/>
-        </a:ln>
-        <a:ln w="25400" cap="flat" cmpd="sng" algn="ctr">
-          <a:solidFill>
-            <a:schemeClr val="phClr"/>
-          </a:solidFill>
-          <a:prstDash val="solid"/>
-        </a:ln>
-        <a:ln w="38100" cap="flat" cmpd="sng" algn="ctr">
-          <a:solidFill>
-            <a:schemeClr val="phClr"/>
-          </a:solidFill>
-          <a:prstDash val="solid"/>
-        </a:ln>
-      </a:lnStyleLst>
-      <a:effectStyleLst>
-        <a:effectStyle>
-          <a:effectLst>
-            <a:outerShdw blurRad="40000" dist="20000" dir="5400000" rotWithShape="0">
-              <a:srgbClr val="000000">
-                <a:alpha val="38000"/>
-              </a:srgbClr>
-            </a:outerShdw>
-          </a:effectLst>
-        </a:effectStyle>
-        <a:effectStyle>
-          <a:effectLst>
-            <a:outerShdw blurRad="40000" dist="23000" dir="5400000" rotWithShape="0">
-              <a:srgbClr val="000000">
-                <a:alpha val="35000"/>
-              </a:srgbClr>
-            </a:outerShdw>
-          </a:effectLst>
-        </a:effectStyle>
-        <a:effectStyle>
-          <a:effectLst>
-            <a:outerShdw blurRad="40000" dist="23000" dir="5400000" rotWithShape="0">
-              <a:srgbClr val="000000">
-                <a:alpha val="35000"/>
-              </a:srgbClr>
-            </a:outerShdw>
-          </a:effectLst>
-          <a:scene3d>
-            <a:camera prst="orthographicFront">
-              <a:rot lat="0" lon="0" rev="0"/>
-            </a:camera>
-            <a:lightRig rig="threePt" dir="t">
-              <a:rot lat="0" lon="0" rev="1200000"/>
-            </a:lightRig>
-          </a:scene3d>
-          <a:sp3d>
-            <a:bevelT w="63500" h="25400"/>
-          </a:sp3d>
-        </a:effectStyle>
-      </a:effectStyleLst>
-      <a:bgFillStyleLst>
-        <a:solidFill>
-          <a:schemeClr val="phClr"/>
-        </a:solidFill>
-        <a:gradFill rotWithShape="1">
-          <a:gsLst>
-            <a:gs pos="0">
-              <a:schemeClr val="phClr">
-                <a:tint val="40000"/>
-                <a:satMod val="350000"/>
-              </a:schemeClr>
-            </a:gs>
-            <a:gs pos="40000">
-              <a:schemeClr val="phClr">
-                <a:tint val="45000"/>
-                <a:shade val="99000"/>
-                <a:satMod val="350000"/>
-              </a:schemeClr>
-            </a:gs>
-            <a:gs pos="100000">
-              <a:schemeClr val="phClr">
-                <a:shade val="20000"/>
-                <a:satMod val="255000"/>
-              </a:schemeClr>
-            </a:gs>
-          </a:gsLst>
-          <a:path path="circle">
-            <a:fillToRect l="50000" t="-80000" r="50000" b="180000"/>
-          </a:path>
-        </a:gradFill>
-        <a:gradFill rotWithShape="1">
-          <a:gsLst>
-            <a:gs pos="0">
-              <a:schemeClr val="phClr">
-                <a:tint val="80000"/>
-                <a:satMod val="300000"/>
-              </a:schemeClr>
-            </a:gs>
-            <a:gs pos="100000">
-              <a:schemeClr val="phClr">
-                <a:shade val="30000"/>
-                <a:satMod val="200000"/>
-              </a:schemeClr>
-            </a:gs>
-          </a:gsLst>
-          <a:path path="circle">
-            <a:fillToRect l="50000" t="50000" r="50000" b="50000"/>
-          </a:path>
-        </a:gradFill>
-      </a:bgFillStyleLst>
-    </a:fmtScheme>
-  </a:themeElements>
-</a:theme>
 </file>
</xml_diff>